<commit_message>
Prepare marketing campaign duration project
</commit_message>
<xml_diff>
--- a/tasks/Specialisation: Marketing Analyst/outputs/marketing_campaign_comparison_presentation.pptx
+++ b/tasks/Specialisation: Marketing Analyst/outputs/marketing_campaign_comparison_presentation.pptx
@@ -2,136 +2,31 @@
 <file path=ppt/presentation.xml><?xml version="1.0" encoding="utf-8"?>
 <p:presentation xmlns:a="http://schemas.openxmlformats.org/drawingml/2006/main" xmlns:r="http://schemas.openxmlformats.org/officeDocument/2006/relationships" xmlns:p="http://schemas.openxmlformats.org/presentationml/2006/main">
   <p:sldMasterIdLst>
-    <p:sldMasterId id="2147483648" r:id="rId1"/>
+    <p:sldMasterId id="2147483648" r:id="rId11"/>
   </p:sldMasterIdLst>
   <p:notesMasterIdLst>
-    <p:notesMasterId r:id="rId12"/>
+    <p:notesMasterId r:id="rId13"/>
   </p:notesMasterIdLst>
   <p:sldIdLst>
-    <p:sldId id="256" r:id="rId2"/>
-    <p:sldId id="257" r:id="rId3"/>
-    <p:sldId id="258" r:id="rId4"/>
-    <p:sldId id="259" r:id="rId5"/>
-    <p:sldId id="260" r:id="rId6"/>
-    <p:sldId id="261" r:id="rId7"/>
-    <p:sldId id="262" r:id="rId8"/>
-    <p:sldId id="263" r:id="rId9"/>
-    <p:sldId id="264" r:id="rId10"/>
-    <p:sldId id="265" r:id="rId11"/>
+    <p:sldId id="256" r:id="rId1"/>
+    <p:sldId id="257" r:id="rId2"/>
+    <p:sldId id="258" r:id="rId3"/>
+    <p:sldId id="259" r:id="rId4"/>
+    <p:sldId id="260" r:id="rId5"/>
+    <p:sldId id="261" r:id="rId6"/>
+    <p:sldId id="262" r:id="rId7"/>
+    <p:sldId id="263" r:id="rId8"/>
+    <p:sldId id="264" r:id="rId9"/>
+    <p:sldId id="265" r:id="rId10"/>
   </p:sldIdLst>
-  <p:sldSz cx="13333413" cy="7499350"/>
+  <p:sldSz cx="13333333" cy="7500000" type="wide"/>
   <p:notesSz cx="6858000" cy="9144000"/>
-  <p:defaultTextStyle>
-    <a:defPPr>
-      <a:defRPr lang="en-BD"/>
-    </a:defPPr>
-    <a:lvl1pPr marL="0" algn="l" defTabSz="914400" rtl="0" eaLnBrk="1" latinLnBrk="0" hangingPunct="1">
-      <a:defRPr sz="1800" kern="1200">
-        <a:solidFill>
-          <a:schemeClr val="tx1"/>
-        </a:solidFill>
-        <a:latin typeface="+mn-lt"/>
-        <a:ea typeface="+mn-ea"/>
-        <a:cs typeface="+mn-cs"/>
-      </a:defRPr>
-    </a:lvl1pPr>
-    <a:lvl2pPr marL="457200" algn="l" defTabSz="914400" rtl="0" eaLnBrk="1" latinLnBrk="0" hangingPunct="1">
-      <a:defRPr sz="1800" kern="1200">
-        <a:solidFill>
-          <a:schemeClr val="tx1"/>
-        </a:solidFill>
-        <a:latin typeface="+mn-lt"/>
-        <a:ea typeface="+mn-ea"/>
-        <a:cs typeface="+mn-cs"/>
-      </a:defRPr>
-    </a:lvl2pPr>
-    <a:lvl3pPr marL="914400" algn="l" defTabSz="914400" rtl="0" eaLnBrk="1" latinLnBrk="0" hangingPunct="1">
-      <a:defRPr sz="1800" kern="1200">
-        <a:solidFill>
-          <a:schemeClr val="tx1"/>
-        </a:solidFill>
-        <a:latin typeface="+mn-lt"/>
-        <a:ea typeface="+mn-ea"/>
-        <a:cs typeface="+mn-cs"/>
-      </a:defRPr>
-    </a:lvl3pPr>
-    <a:lvl4pPr marL="1371600" algn="l" defTabSz="914400" rtl="0" eaLnBrk="1" latinLnBrk="0" hangingPunct="1">
-      <a:defRPr sz="1800" kern="1200">
-        <a:solidFill>
-          <a:schemeClr val="tx1"/>
-        </a:solidFill>
-        <a:latin typeface="+mn-lt"/>
-        <a:ea typeface="+mn-ea"/>
-        <a:cs typeface="+mn-cs"/>
-      </a:defRPr>
-    </a:lvl4pPr>
-    <a:lvl5pPr marL="1828800" algn="l" defTabSz="914400" rtl="0" eaLnBrk="1" latinLnBrk="0" hangingPunct="1">
-      <a:defRPr sz="1800" kern="1200">
-        <a:solidFill>
-          <a:schemeClr val="tx1"/>
-        </a:solidFill>
-        <a:latin typeface="+mn-lt"/>
-        <a:ea typeface="+mn-ea"/>
-        <a:cs typeface="+mn-cs"/>
-      </a:defRPr>
-    </a:lvl5pPr>
-    <a:lvl6pPr marL="2286000" algn="l" defTabSz="914400" rtl="0" eaLnBrk="1" latinLnBrk="0" hangingPunct="1">
-      <a:defRPr sz="1800" kern="1200">
-        <a:solidFill>
-          <a:schemeClr val="tx1"/>
-        </a:solidFill>
-        <a:latin typeface="+mn-lt"/>
-        <a:ea typeface="+mn-ea"/>
-        <a:cs typeface="+mn-cs"/>
-      </a:defRPr>
-    </a:lvl6pPr>
-    <a:lvl7pPr marL="2743200" algn="l" defTabSz="914400" rtl="0" eaLnBrk="1" latinLnBrk="0" hangingPunct="1">
-      <a:defRPr sz="1800" kern="1200">
-        <a:solidFill>
-          <a:schemeClr val="tx1"/>
-        </a:solidFill>
-        <a:latin typeface="+mn-lt"/>
-        <a:ea typeface="+mn-ea"/>
-        <a:cs typeface="+mn-cs"/>
-      </a:defRPr>
-    </a:lvl7pPr>
-    <a:lvl8pPr marL="3200400" algn="l" defTabSz="914400" rtl="0" eaLnBrk="1" latinLnBrk="0" hangingPunct="1">
-      <a:defRPr sz="1800" kern="1200">
-        <a:solidFill>
-          <a:schemeClr val="tx1"/>
-        </a:solidFill>
-        <a:latin typeface="+mn-lt"/>
-        <a:ea typeface="+mn-ea"/>
-        <a:cs typeface="+mn-cs"/>
-      </a:defRPr>
-    </a:lvl8pPr>
-    <a:lvl9pPr marL="3657600" algn="l" defTabSz="914400" rtl="0" eaLnBrk="1" latinLnBrk="0" hangingPunct="1">
-      <a:defRPr sz="1800" kern="1200">
-        <a:solidFill>
-          <a:schemeClr val="tx1"/>
-        </a:solidFill>
-        <a:latin typeface="+mn-lt"/>
-        <a:ea typeface="+mn-ea"/>
-        <a:cs typeface="+mn-cs"/>
-      </a:defRPr>
-    </a:lvl9pPr>
-  </p:defaultTextStyle>
-  <p:extLst>
-    <p:ext uri="{EFAFB233-063F-42B5-8137-9DF3F51BA10A}">
-      <p15:sldGuideLst xmlns:p15="http://schemas.microsoft.com/office/powerpoint/2012/main"/>
-    </p:ext>
-  </p:extLst>
 </p:presentation>
 </file>
 
 <file path=ppt/notesMasters/notesMaster1.xml><?xml version="1.0" encoding="utf-8"?>
 <p:notesMaster xmlns:a="http://schemas.openxmlformats.org/drawingml/2006/main" xmlns:r="http://schemas.openxmlformats.org/officeDocument/2006/relationships" xmlns:p="http://schemas.openxmlformats.org/presentationml/2006/main">
   <p:cSld>
-    <p:bg>
-      <p:bgRef idx="1001">
-        <a:schemeClr val="bg1"/>
-      </p:bgRef>
-    </p:bg>
     <p:spTree>
       <p:nvGrpSpPr>
         <p:cNvPr id="1" name=""/>
@@ -149,98 +44,6 @@
     </p:spTree>
   </p:cSld>
   <p:clrMap bg1="lt1" tx1="dk1" bg2="lt2" tx2="dk2" accent1="accent1" accent2="accent2" accent3="accent3" accent4="accent4" accent5="accent5" accent6="accent6" hlink="hlink" folHlink="folHlink"/>
-  <p:notesStyle>
-    <a:lvl1pPr marL="0" algn="l" defTabSz="914400" rtl="0" eaLnBrk="1" latinLnBrk="0" hangingPunct="1">
-      <a:defRPr sz="1200" kern="1200">
-        <a:solidFill>
-          <a:schemeClr val="tx1"/>
-        </a:solidFill>
-        <a:latin typeface="+mn-lt"/>
-        <a:ea typeface="+mn-ea"/>
-        <a:cs typeface="+mn-cs"/>
-      </a:defRPr>
-    </a:lvl1pPr>
-    <a:lvl2pPr marL="457200" algn="l" defTabSz="914400" rtl="0" eaLnBrk="1" latinLnBrk="0" hangingPunct="1">
-      <a:defRPr sz="1200" kern="1200">
-        <a:solidFill>
-          <a:schemeClr val="tx1"/>
-        </a:solidFill>
-        <a:latin typeface="+mn-lt"/>
-        <a:ea typeface="+mn-ea"/>
-        <a:cs typeface="+mn-cs"/>
-      </a:defRPr>
-    </a:lvl2pPr>
-    <a:lvl3pPr marL="914400" algn="l" defTabSz="914400" rtl="0" eaLnBrk="1" latinLnBrk="0" hangingPunct="1">
-      <a:defRPr sz="1200" kern="1200">
-        <a:solidFill>
-          <a:schemeClr val="tx1"/>
-        </a:solidFill>
-        <a:latin typeface="+mn-lt"/>
-        <a:ea typeface="+mn-ea"/>
-        <a:cs typeface="+mn-cs"/>
-      </a:defRPr>
-    </a:lvl3pPr>
-    <a:lvl4pPr marL="1371600" algn="l" defTabSz="914400" rtl="0" eaLnBrk="1" latinLnBrk="0" hangingPunct="1">
-      <a:defRPr sz="1200" kern="1200">
-        <a:solidFill>
-          <a:schemeClr val="tx1"/>
-        </a:solidFill>
-        <a:latin typeface="+mn-lt"/>
-        <a:ea typeface="+mn-ea"/>
-        <a:cs typeface="+mn-cs"/>
-      </a:defRPr>
-    </a:lvl4pPr>
-    <a:lvl5pPr marL="1828800" algn="l" defTabSz="914400" rtl="0" eaLnBrk="1" latinLnBrk="0" hangingPunct="1">
-      <a:defRPr sz="1200" kern="1200">
-        <a:solidFill>
-          <a:schemeClr val="tx1"/>
-        </a:solidFill>
-        <a:latin typeface="+mn-lt"/>
-        <a:ea typeface="+mn-ea"/>
-        <a:cs typeface="+mn-cs"/>
-      </a:defRPr>
-    </a:lvl5pPr>
-    <a:lvl6pPr marL="2286000" algn="l" defTabSz="914400" rtl="0" eaLnBrk="1" latinLnBrk="0" hangingPunct="1">
-      <a:defRPr sz="1200" kern="1200">
-        <a:solidFill>
-          <a:schemeClr val="tx1"/>
-        </a:solidFill>
-        <a:latin typeface="+mn-lt"/>
-        <a:ea typeface="+mn-ea"/>
-        <a:cs typeface="+mn-cs"/>
-      </a:defRPr>
-    </a:lvl6pPr>
-    <a:lvl7pPr marL="2743200" algn="l" defTabSz="914400" rtl="0" eaLnBrk="1" latinLnBrk="0" hangingPunct="1">
-      <a:defRPr sz="1200" kern="1200">
-        <a:solidFill>
-          <a:schemeClr val="tx1"/>
-        </a:solidFill>
-        <a:latin typeface="+mn-lt"/>
-        <a:ea typeface="+mn-ea"/>
-        <a:cs typeface="+mn-cs"/>
-      </a:defRPr>
-    </a:lvl7pPr>
-    <a:lvl8pPr marL="3200400" algn="l" defTabSz="914400" rtl="0" eaLnBrk="1" latinLnBrk="0" hangingPunct="1">
-      <a:defRPr sz="1200" kern="1200">
-        <a:solidFill>
-          <a:schemeClr val="tx1"/>
-        </a:solidFill>
-        <a:latin typeface="+mn-lt"/>
-        <a:ea typeface="+mn-ea"/>
-        <a:cs typeface="+mn-cs"/>
-      </a:defRPr>
-    </a:lvl8pPr>
-    <a:lvl9pPr marL="3657600" algn="l" defTabSz="914400" rtl="0" eaLnBrk="1" latinLnBrk="0" hangingPunct="1">
-      <a:defRPr sz="1200" kern="1200">
-        <a:solidFill>
-          <a:schemeClr val="tx1"/>
-        </a:solidFill>
-        <a:latin typeface="+mn-lt"/>
-        <a:ea typeface="+mn-ea"/>
-        <a:cs typeface="+mn-cs"/>
-      </a:defRPr>
-    </a:lvl9pPr>
-  </p:notesStyle>
 </p:notesMaster>
 </file>
 
@@ -451,7 +254,7 @@
           <a:p>
             <a:r>
               <a:rPr lang="en-US" sz="1200"/>
-              <a:t>This slide teaches the session modeling logic. It also prepares the reviewer for questions about how time on site was interpreted.</a:t>
+              <a:t>This slide teaches the session modeling logic. It also prepares for questions about how time on site was interpreted.</a:t>
             </a:r>
           </a:p>
         </p:txBody>
@@ -616,7 +419,7 @@
           <a:p>
             <a:r>
               <a:rPr lang="en-US" sz="1200"/>
-              <a:t>Use this slide to answer the likely review question and explain why high averages from tiny samples are not enough for a budget decision.</a:t>
+              <a:t>Use this slide to answer the likely stakeholder question and explain why high averages from tiny samples are not enough for a budget decision.</a:t>
             </a:r>
           </a:p>
         </p:txBody>
@@ -726,7 +529,7 @@
           <a:p>
             <a:r>
               <a:rPr lang="en-US" sz="1200"/>
-              <a:t>This slide shows analytical maturity. Name the assumptions and boundaries clearly so the reviewer knows you understand the metric.</a:t>
+              <a:t>This slide shows analytical maturity. Name the assumptions and boundaries clearly so the metric is easy to defend.</a:t>
             </a:r>
           </a:p>
         </p:txBody>
@@ -822,11 +625,6 @@
 <file path=ppt/slideMasters/slideMaster1.xml><?xml version="1.0" encoding="utf-8"?>
 <p:sldMaster xmlns:a="http://schemas.openxmlformats.org/drawingml/2006/main" xmlns:r="http://schemas.openxmlformats.org/officeDocument/2006/relationships" xmlns:p="http://schemas.openxmlformats.org/presentationml/2006/main">
   <p:cSld>
-    <p:bg>
-      <p:bgRef idx="1001">
-        <a:schemeClr val="bg1"/>
-      </p:bgRef>
-    </p:bg>
     <p:spTree>
       <p:nvGrpSpPr>
         <p:cNvPr id="1" name=""/>
@@ -847,286 +645,6 @@
   <p:sldLayoutIdLst>
     <p:sldLayoutId id="2147483649" r:id="rId1"/>
   </p:sldLayoutIdLst>
-  <p:txStyles>
-    <p:titleStyle>
-      <a:lvl1pPr algn="l" defTabSz="914400" rtl="0" eaLnBrk="1" latinLnBrk="0" hangingPunct="1">
-        <a:lnSpc>
-          <a:spcPct val="90000"/>
-        </a:lnSpc>
-        <a:spcBef>
-          <a:spcPct val="0"/>
-        </a:spcBef>
-        <a:buNone/>
-        <a:defRPr sz="4400" kern="1200">
-          <a:solidFill>
-            <a:schemeClr val="tx1"/>
-          </a:solidFill>
-          <a:latin typeface="+mj-lt"/>
-          <a:ea typeface="+mj-ea"/>
-          <a:cs typeface="+mj-cs"/>
-        </a:defRPr>
-      </a:lvl1pPr>
-    </p:titleStyle>
-    <p:bodyStyle>
-      <a:lvl1pPr marL="228600" indent="-228600" algn="l" defTabSz="914400" rtl="0" eaLnBrk="1" latinLnBrk="0" hangingPunct="1">
-        <a:lnSpc>
-          <a:spcPct val="90000"/>
-        </a:lnSpc>
-        <a:spcBef>
-          <a:spcPts val="1000"/>
-        </a:spcBef>
-        <a:buFont typeface="Arial" panose="020B0604020202020204" pitchFamily="34" charset="0"/>
-        <a:buChar char="•"/>
-        <a:defRPr sz="2800" kern="1200">
-          <a:solidFill>
-            <a:schemeClr val="tx1"/>
-          </a:solidFill>
-          <a:latin typeface="+mn-lt"/>
-          <a:ea typeface="+mn-ea"/>
-          <a:cs typeface="+mn-cs"/>
-        </a:defRPr>
-      </a:lvl1pPr>
-      <a:lvl2pPr marL="685800" indent="-228600" algn="l" defTabSz="914400" rtl="0" eaLnBrk="1" latinLnBrk="0" hangingPunct="1">
-        <a:lnSpc>
-          <a:spcPct val="90000"/>
-        </a:lnSpc>
-        <a:spcBef>
-          <a:spcPts val="500"/>
-        </a:spcBef>
-        <a:buFont typeface="Arial" panose="020B0604020202020204" pitchFamily="34" charset="0"/>
-        <a:buChar char="•"/>
-        <a:defRPr sz="2400" kern="1200">
-          <a:solidFill>
-            <a:schemeClr val="tx1"/>
-          </a:solidFill>
-          <a:latin typeface="+mn-lt"/>
-          <a:ea typeface="+mn-ea"/>
-          <a:cs typeface="+mn-cs"/>
-        </a:defRPr>
-      </a:lvl2pPr>
-      <a:lvl3pPr marL="1143000" indent="-228600" algn="l" defTabSz="914400" rtl="0" eaLnBrk="1" latinLnBrk="0" hangingPunct="1">
-        <a:lnSpc>
-          <a:spcPct val="90000"/>
-        </a:lnSpc>
-        <a:spcBef>
-          <a:spcPts val="500"/>
-        </a:spcBef>
-        <a:buFont typeface="Arial" panose="020B0604020202020204" pitchFamily="34" charset="0"/>
-        <a:buChar char="•"/>
-        <a:defRPr sz="2000" kern="1200">
-          <a:solidFill>
-            <a:schemeClr val="tx1"/>
-          </a:solidFill>
-          <a:latin typeface="+mn-lt"/>
-          <a:ea typeface="+mn-ea"/>
-          <a:cs typeface="+mn-cs"/>
-        </a:defRPr>
-      </a:lvl3pPr>
-      <a:lvl4pPr marL="1600200" indent="-228600" algn="l" defTabSz="914400" rtl="0" eaLnBrk="1" latinLnBrk="0" hangingPunct="1">
-        <a:lnSpc>
-          <a:spcPct val="90000"/>
-        </a:lnSpc>
-        <a:spcBef>
-          <a:spcPts val="500"/>
-        </a:spcBef>
-        <a:buFont typeface="Arial" panose="020B0604020202020204" pitchFamily="34" charset="0"/>
-        <a:buChar char="•"/>
-        <a:defRPr sz="1800" kern="1200">
-          <a:solidFill>
-            <a:schemeClr val="tx1"/>
-          </a:solidFill>
-          <a:latin typeface="+mn-lt"/>
-          <a:ea typeface="+mn-ea"/>
-          <a:cs typeface="+mn-cs"/>
-        </a:defRPr>
-      </a:lvl4pPr>
-      <a:lvl5pPr marL="2057400" indent="-228600" algn="l" defTabSz="914400" rtl="0" eaLnBrk="1" latinLnBrk="0" hangingPunct="1">
-        <a:lnSpc>
-          <a:spcPct val="90000"/>
-        </a:lnSpc>
-        <a:spcBef>
-          <a:spcPts val="500"/>
-        </a:spcBef>
-        <a:buFont typeface="Arial" panose="020B0604020202020204" pitchFamily="34" charset="0"/>
-        <a:buChar char="•"/>
-        <a:defRPr sz="1800" kern="1200">
-          <a:solidFill>
-            <a:schemeClr val="tx1"/>
-          </a:solidFill>
-          <a:latin typeface="+mn-lt"/>
-          <a:ea typeface="+mn-ea"/>
-          <a:cs typeface="+mn-cs"/>
-        </a:defRPr>
-      </a:lvl5pPr>
-      <a:lvl6pPr marL="2514600" indent="-228600" algn="l" defTabSz="914400" rtl="0" eaLnBrk="1" latinLnBrk="0" hangingPunct="1">
-        <a:lnSpc>
-          <a:spcPct val="90000"/>
-        </a:lnSpc>
-        <a:spcBef>
-          <a:spcPts val="500"/>
-        </a:spcBef>
-        <a:buFont typeface="Arial" panose="020B0604020202020204" pitchFamily="34" charset="0"/>
-        <a:buChar char="•"/>
-        <a:defRPr sz="1800" kern="1200">
-          <a:solidFill>
-            <a:schemeClr val="tx1"/>
-          </a:solidFill>
-          <a:latin typeface="+mn-lt"/>
-          <a:ea typeface="+mn-ea"/>
-          <a:cs typeface="+mn-cs"/>
-        </a:defRPr>
-      </a:lvl6pPr>
-      <a:lvl7pPr marL="2971800" indent="-228600" algn="l" defTabSz="914400" rtl="0" eaLnBrk="1" latinLnBrk="0" hangingPunct="1">
-        <a:lnSpc>
-          <a:spcPct val="90000"/>
-        </a:lnSpc>
-        <a:spcBef>
-          <a:spcPts val="500"/>
-        </a:spcBef>
-        <a:buFont typeface="Arial" panose="020B0604020202020204" pitchFamily="34" charset="0"/>
-        <a:buChar char="•"/>
-        <a:defRPr sz="1800" kern="1200">
-          <a:solidFill>
-            <a:schemeClr val="tx1"/>
-          </a:solidFill>
-          <a:latin typeface="+mn-lt"/>
-          <a:ea typeface="+mn-ea"/>
-          <a:cs typeface="+mn-cs"/>
-        </a:defRPr>
-      </a:lvl7pPr>
-      <a:lvl8pPr marL="3429000" indent="-228600" algn="l" defTabSz="914400" rtl="0" eaLnBrk="1" latinLnBrk="0" hangingPunct="1">
-        <a:lnSpc>
-          <a:spcPct val="90000"/>
-        </a:lnSpc>
-        <a:spcBef>
-          <a:spcPts val="500"/>
-        </a:spcBef>
-        <a:buFont typeface="Arial" panose="020B0604020202020204" pitchFamily="34" charset="0"/>
-        <a:buChar char="•"/>
-        <a:defRPr sz="1800" kern="1200">
-          <a:solidFill>
-            <a:schemeClr val="tx1"/>
-          </a:solidFill>
-          <a:latin typeface="+mn-lt"/>
-          <a:ea typeface="+mn-ea"/>
-          <a:cs typeface="+mn-cs"/>
-        </a:defRPr>
-      </a:lvl8pPr>
-      <a:lvl9pPr marL="3886200" indent="-228600" algn="l" defTabSz="914400" rtl="0" eaLnBrk="1" latinLnBrk="0" hangingPunct="1">
-        <a:lnSpc>
-          <a:spcPct val="90000"/>
-        </a:lnSpc>
-        <a:spcBef>
-          <a:spcPts val="500"/>
-        </a:spcBef>
-        <a:buFont typeface="Arial" panose="020B0604020202020204" pitchFamily="34" charset="0"/>
-        <a:buChar char="•"/>
-        <a:defRPr sz="1800" kern="1200">
-          <a:solidFill>
-            <a:schemeClr val="tx1"/>
-          </a:solidFill>
-          <a:latin typeface="+mn-lt"/>
-          <a:ea typeface="+mn-ea"/>
-          <a:cs typeface="+mn-cs"/>
-        </a:defRPr>
-      </a:lvl9pPr>
-    </p:bodyStyle>
-    <p:otherStyle>
-      <a:defPPr>
-        <a:defRPr lang="en-BD"/>
-      </a:defPPr>
-      <a:lvl1pPr marL="0" algn="l" defTabSz="914400" rtl="0" eaLnBrk="1" latinLnBrk="0" hangingPunct="1">
-        <a:defRPr sz="1800" kern="1200">
-          <a:solidFill>
-            <a:schemeClr val="tx1"/>
-          </a:solidFill>
-          <a:latin typeface="+mn-lt"/>
-          <a:ea typeface="+mn-ea"/>
-          <a:cs typeface="+mn-cs"/>
-        </a:defRPr>
-      </a:lvl1pPr>
-      <a:lvl2pPr marL="457200" algn="l" defTabSz="914400" rtl="0" eaLnBrk="1" latinLnBrk="0" hangingPunct="1">
-        <a:defRPr sz="1800" kern="1200">
-          <a:solidFill>
-            <a:schemeClr val="tx1"/>
-          </a:solidFill>
-          <a:latin typeface="+mn-lt"/>
-          <a:ea typeface="+mn-ea"/>
-          <a:cs typeface="+mn-cs"/>
-        </a:defRPr>
-      </a:lvl2pPr>
-      <a:lvl3pPr marL="914400" algn="l" defTabSz="914400" rtl="0" eaLnBrk="1" latinLnBrk="0" hangingPunct="1">
-        <a:defRPr sz="1800" kern="1200">
-          <a:solidFill>
-            <a:schemeClr val="tx1"/>
-          </a:solidFill>
-          <a:latin typeface="+mn-lt"/>
-          <a:ea typeface="+mn-ea"/>
-          <a:cs typeface="+mn-cs"/>
-        </a:defRPr>
-      </a:lvl3pPr>
-      <a:lvl4pPr marL="1371600" algn="l" defTabSz="914400" rtl="0" eaLnBrk="1" latinLnBrk="0" hangingPunct="1">
-        <a:defRPr sz="1800" kern="1200">
-          <a:solidFill>
-            <a:schemeClr val="tx1"/>
-          </a:solidFill>
-          <a:latin typeface="+mn-lt"/>
-          <a:ea typeface="+mn-ea"/>
-          <a:cs typeface="+mn-cs"/>
-        </a:defRPr>
-      </a:lvl4pPr>
-      <a:lvl5pPr marL="1828800" algn="l" defTabSz="914400" rtl="0" eaLnBrk="1" latinLnBrk="0" hangingPunct="1">
-        <a:defRPr sz="1800" kern="1200">
-          <a:solidFill>
-            <a:schemeClr val="tx1"/>
-          </a:solidFill>
-          <a:latin typeface="+mn-lt"/>
-          <a:ea typeface="+mn-ea"/>
-          <a:cs typeface="+mn-cs"/>
-        </a:defRPr>
-      </a:lvl5pPr>
-      <a:lvl6pPr marL="2286000" algn="l" defTabSz="914400" rtl="0" eaLnBrk="1" latinLnBrk="0" hangingPunct="1">
-        <a:defRPr sz="1800" kern="1200">
-          <a:solidFill>
-            <a:schemeClr val="tx1"/>
-          </a:solidFill>
-          <a:latin typeface="+mn-lt"/>
-          <a:ea typeface="+mn-ea"/>
-          <a:cs typeface="+mn-cs"/>
-        </a:defRPr>
-      </a:lvl6pPr>
-      <a:lvl7pPr marL="2743200" algn="l" defTabSz="914400" rtl="0" eaLnBrk="1" latinLnBrk="0" hangingPunct="1">
-        <a:defRPr sz="1800" kern="1200">
-          <a:solidFill>
-            <a:schemeClr val="tx1"/>
-          </a:solidFill>
-          <a:latin typeface="+mn-lt"/>
-          <a:ea typeface="+mn-ea"/>
-          <a:cs typeface="+mn-cs"/>
-        </a:defRPr>
-      </a:lvl7pPr>
-      <a:lvl8pPr marL="3200400" algn="l" defTabSz="914400" rtl="0" eaLnBrk="1" latinLnBrk="0" hangingPunct="1">
-        <a:defRPr sz="1800" kern="1200">
-          <a:solidFill>
-            <a:schemeClr val="tx1"/>
-          </a:solidFill>
-          <a:latin typeface="+mn-lt"/>
-          <a:ea typeface="+mn-ea"/>
-          <a:cs typeface="+mn-cs"/>
-        </a:defRPr>
-      </a:lvl8pPr>
-      <a:lvl9pPr marL="3657600" algn="l" defTabSz="914400" rtl="0" eaLnBrk="1" latinLnBrk="0" hangingPunct="1">
-        <a:defRPr sz="1800" kern="1200">
-          <a:solidFill>
-            <a:schemeClr val="tx1"/>
-          </a:solidFill>
-          <a:latin typeface="+mn-lt"/>
-          <a:ea typeface="+mn-ea"/>
-          <a:cs typeface="+mn-cs"/>
-        </a:defRPr>
-      </a:lvl9pPr>
-    </p:otherStyle>
-  </p:txStyles>
 </p:sldMaster>
 </file>
 
@@ -1138,7 +656,6 @@
         <a:solidFill>
           <a:srgbClr val="1F2933"/>
         </a:solidFill>
-        <a:effectLst/>
       </p:bgPr>
     </p:bg>
     <p:spTree>
@@ -1179,9 +696,7 @@
         <p:txBody>
           <a:bodyPr/>
           <a:lstStyle/>
-          <a:p>
-            <a:endParaRPr/>
-          </a:p>
+          <a:p/>
         </p:txBody>
       </p:sp>
       <p:sp>
@@ -1343,7 +858,7 @@
                 </a:solidFill>
                 <a:latin typeface="Arial"/>
               </a:rPr>
-              <a:t>Source: tc-da-1.turing_data_analytics.raw_events</a:t>
+              <a:t>Source: BigQuery raw events export</a:t>
             </a:r>
           </a:p>
         </p:txBody>
@@ -1364,7 +879,6 @@
         <a:solidFill>
           <a:srgbClr val="F7F9FC"/>
         </a:solidFill>
-        <a:effectLst/>
       </p:bgPr>
     </p:bg>
     <p:spTree>
@@ -1525,7 +1039,7 @@
         <p:spPr>
           <a:xfrm>
             <a:off x="1143000" y="2952750"/>
-            <a:ext cx="9715500" cy="1162048"/>
+            <a:ext cx="9715500" cy="1000125"/>
           </a:xfrm>
           <a:prstGeom prst="roundRect">
             <a:avLst/>
@@ -1542,9 +1056,7 @@
         <p:txBody>
           <a:bodyPr/>
           <a:lstStyle/>
-          <a:p>
-            <a:endParaRPr/>
-          </a:p>
+          <a:p/>
         </p:txBody>
       </p:sp>
       <p:sp>
@@ -1572,7 +1084,7 @@
           </a:bodyPr>
           <a:lstStyle/>
           <a:p>
-            <a:pPr algn="l"/>
+            <a:pPr algn="c"/>
             <a:r>
               <a:rPr lang="en-US" sz="2000" b="1">
                 <a:solidFill>
@@ -1609,9 +1121,7 @@
         <p:txBody>
           <a:bodyPr/>
           <a:lstStyle/>
-          <a:p>
-            <a:endParaRPr/>
-          </a:p>
+          <a:p/>
         </p:txBody>
       </p:sp>
       <p:sp>
@@ -1676,9 +1186,7 @@
         <p:txBody>
           <a:bodyPr/>
           <a:lstStyle/>
-          <a:p>
-            <a:endParaRPr/>
-          </a:p>
+          <a:p/>
         </p:txBody>
       </p:sp>
       <p:sp>
@@ -1743,9 +1251,7 @@
         <p:txBody>
           <a:bodyPr/>
           <a:lstStyle/>
-          <a:p>
-            <a:endParaRPr/>
-          </a:p>
+          <a:p/>
         </p:txBody>
       </p:sp>
       <p:sp>
@@ -1802,7 +1308,6 @@
         <a:solidFill>
           <a:srgbClr val="F7F9FC"/>
         </a:solidFill>
-        <a:effectLst/>
       </p:bgPr>
     </p:bg>
     <p:spTree>
@@ -1904,25 +1409,25 @@
         <p:spPr>
           <a:xfrm>
             <a:off x="666750" y="1771650"/>
-            <a:ext cx="11234098" cy="400110"/>
-          </a:xfrm>
-          <a:prstGeom prst="rect">
-            <a:avLst/>
-          </a:prstGeom>
-          <a:noFill/>
-          <a:ln>
-            <a:noFill/>
-          </a:ln>
-        </p:spPr>
-        <p:txBody>
-          <a:bodyPr wrap="square" anchor="t">
-            <a:spAutoFit/>
-          </a:bodyPr>
-          <a:lstStyle/>
-          <a:p>
-            <a:pPr algn="l"/>
-            <a:r>
-              <a:rPr lang="en-US" sz="2000" dirty="0">
+            <a:ext cx="10287000" cy="438150"/>
+          </a:xfrm>
+          <a:prstGeom prst="rect">
+            <a:avLst/>
+          </a:prstGeom>
+          <a:noFill/>
+          <a:ln>
+            <a:noFill/>
+          </a:ln>
+        </p:spPr>
+        <p:txBody>
+          <a:bodyPr wrap="square" anchor="t">
+            <a:spAutoFit/>
+          </a:bodyPr>
+          <a:lstStyle/>
+          <a:p>
+            <a:pPr algn="l"/>
+            <a:r>
+              <a:rPr lang="en-US" sz="2000">
                 <a:solidFill>
                   <a:srgbClr val="5F6B7A"/>
                 </a:solidFill>
@@ -1978,9 +1483,7 @@
         <p:txBody>
           <a:bodyPr/>
           <a:lstStyle/>
-          <a:p>
-            <a:endParaRPr/>
-          </a:p>
+          <a:p/>
         </p:txBody>
       </p:sp>
       <p:sp>
@@ -2010,7 +1513,7 @@
           <a:p>
             <a:pPr algn="l"/>
             <a:r>
-              <a:rPr lang="en-US" sz="2000" dirty="0">
+              <a:rPr lang="en-US" sz="2000">
                 <a:solidFill>
                   <a:srgbClr val="1F2933"/>
                 </a:solidFill>
@@ -2045,9 +1548,7 @@
         <p:txBody>
           <a:bodyPr/>
           <a:lstStyle/>
-          <a:p>
-            <a:endParaRPr/>
-          </a:p>
+          <a:p/>
         </p:txBody>
       </p:sp>
       <p:sp>
@@ -2112,9 +1613,7 @@
         <p:txBody>
           <a:bodyPr/>
           <a:lstStyle/>
-          <a:p>
-            <a:endParaRPr/>
-          </a:p>
+          <a:p/>
         </p:txBody>
       </p:sp>
       <p:sp>
@@ -2163,8 +1662,8 @@
         </p:nvSpPr>
         <p:spPr>
           <a:xfrm>
-            <a:off x="7810500" y="2952749"/>
-            <a:ext cx="3048000" cy="2301631"/>
+            <a:off x="7810500" y="2952750"/>
+            <a:ext cx="3048000" cy="2000250"/>
           </a:xfrm>
           <a:prstGeom prst="roundRect">
             <a:avLst/>
@@ -2181,9 +1680,7 @@
         <p:txBody>
           <a:bodyPr/>
           <a:lstStyle/>
-          <a:p>
-            <a:endParaRPr/>
-          </a:p>
+          <a:p/>
         </p:txBody>
       </p:sp>
       <p:sp>
@@ -2211,7 +1708,7 @@
           </a:bodyPr>
           <a:lstStyle/>
           <a:p>
-            <a:pPr algn="l"/>
+            <a:pPr algn="c"/>
             <a:r>
               <a:rPr lang="en-US" sz="2000" b="1">
                 <a:solidFill>
@@ -2249,9 +1746,9 @@
           </a:bodyPr>
           <a:lstStyle/>
           <a:p>
-            <a:pPr algn="l"/>
-            <a:r>
-              <a:rPr lang="en-US" sz="2000" dirty="0">
+            <a:pPr algn="c"/>
+            <a:r>
+              <a:rPr lang="en-US" sz="2000">
                 <a:solidFill>
                   <a:srgbClr val="1F2933"/>
                 </a:solidFill>
@@ -2261,9 +1758,9 @@
             </a:r>
           </a:p>
           <a:p>
-            <a:pPr algn="l"/>
-            <a:r>
-              <a:rPr lang="en-US" sz="2000" dirty="0">
+            <a:pPr algn="c"/>
+            <a:r>
+              <a:rPr lang="en-US" sz="2000">
                 <a:solidFill>
                   <a:srgbClr val="1F2933"/>
                 </a:solidFill>
@@ -2290,7 +1787,6 @@
         <a:solidFill>
           <a:srgbClr val="F7F9FC"/>
         </a:solidFill>
-        <a:effectLst/>
       </p:bgPr>
     </p:bg>
     <p:spTree>
@@ -2468,9 +1964,7 @@
         <p:txBody>
           <a:bodyPr/>
           <a:lstStyle/>
-          <a:p>
-            <a:endParaRPr/>
-          </a:p>
+          <a:p/>
         </p:txBody>
       </p:sp>
       <p:sp>
@@ -2498,7 +1992,7 @@
           </a:bodyPr>
           <a:lstStyle/>
           <a:p>
-            <a:pPr algn="l"/>
+            <a:pPr algn="c"/>
             <a:r>
               <a:rPr lang="en-US" sz="2000" b="1">
                 <a:solidFill>
@@ -2520,25 +2014,25 @@
         <p:spPr>
           <a:xfrm>
             <a:off x="819150" y="3933825"/>
-            <a:ext cx="1981200" cy="646331"/>
-          </a:xfrm>
-          <a:prstGeom prst="rect">
-            <a:avLst/>
-          </a:prstGeom>
-          <a:noFill/>
-          <a:ln>
-            <a:noFill/>
-          </a:ln>
-        </p:spPr>
-        <p:txBody>
-          <a:bodyPr wrap="square" anchor="t">
-            <a:spAutoFit/>
-          </a:bodyPr>
-          <a:lstStyle/>
-          <a:p>
-            <a:pPr algn="l"/>
-            <a:r>
-              <a:rPr lang="en-US" dirty="0">
+            <a:ext cx="1981200" cy="533400"/>
+          </a:xfrm>
+          <a:prstGeom prst="rect">
+            <a:avLst/>
+          </a:prstGeom>
+          <a:noFill/>
+          <a:ln>
+            <a:noFill/>
+          </a:ln>
+        </p:spPr>
+        <p:txBody>
+          <a:bodyPr wrap="square" anchor="t">
+            <a:spAutoFit/>
+          </a:bodyPr>
+          <a:lstStyle/>
+          <a:p>
+            <a:pPr algn="c"/>
+            <a:r>
+              <a:rPr lang="en-US" sz="2000">
                 <a:solidFill>
                   <a:srgbClr val="5F6B7A"/>
                 </a:solidFill>
@@ -2548,9 +2042,9 @@
             </a:r>
           </a:p>
           <a:p>
-            <a:pPr algn="l"/>
-            <a:r>
-              <a:rPr lang="en-US" dirty="0">
+            <a:pPr algn="c"/>
+            <a:r>
+              <a:rPr lang="en-US" sz="2000">
                 <a:solidFill>
                   <a:srgbClr val="5F6B7A"/>
                 </a:solidFill>
@@ -2569,8 +2063,8 @@
         </p:nvSpPr>
         <p:spPr>
           <a:xfrm>
-            <a:off x="3039754" y="3638557"/>
-            <a:ext cx="366359" cy="304792"/>
+            <a:off x="3067050" y="3619500"/>
+            <a:ext cx="523875" cy="323850"/>
           </a:xfrm>
           <a:prstGeom prst="rightArrow">
             <a:avLst/>
@@ -2585,9 +2079,7 @@
         <p:txBody>
           <a:bodyPr/>
           <a:lstStyle/>
-          <a:p>
-            <a:endParaRPr/>
-          </a:p>
+          <a:p/>
         </p:txBody>
       </p:sp>
       <p:sp>
@@ -2616,9 +2108,7 @@
         <p:txBody>
           <a:bodyPr/>
           <a:lstStyle/>
-          <a:p>
-            <a:endParaRPr/>
-          </a:p>
+          <a:p/>
         </p:txBody>
       </p:sp>
       <p:sp>
@@ -2646,7 +2136,7 @@
           </a:bodyPr>
           <a:lstStyle/>
           <a:p>
-            <a:pPr algn="l"/>
+            <a:pPr algn="c"/>
             <a:r>
               <a:rPr lang="en-US" sz="2000" b="1">
                 <a:solidFill>
@@ -2668,25 +2158,25 @@
         <p:spPr>
           <a:xfrm>
             <a:off x="3629025" y="3933825"/>
-            <a:ext cx="1981200" cy="646331"/>
-          </a:xfrm>
-          <a:prstGeom prst="rect">
-            <a:avLst/>
-          </a:prstGeom>
-          <a:noFill/>
-          <a:ln>
-            <a:noFill/>
-          </a:ln>
-        </p:spPr>
-        <p:txBody>
-          <a:bodyPr wrap="square" anchor="t">
-            <a:spAutoFit/>
-          </a:bodyPr>
-          <a:lstStyle/>
-          <a:p>
-            <a:pPr algn="l"/>
-            <a:r>
-              <a:rPr lang="en-US" dirty="0">
+            <a:ext cx="1981200" cy="533400"/>
+          </a:xfrm>
+          <a:prstGeom prst="rect">
+            <a:avLst/>
+          </a:prstGeom>
+          <a:noFill/>
+          <a:ln>
+            <a:noFill/>
+          </a:ln>
+        </p:spPr>
+        <p:txBody>
+          <a:bodyPr wrap="square" anchor="t">
+            <a:spAutoFit/>
+          </a:bodyPr>
+          <a:lstStyle/>
+          <a:p>
+            <a:pPr algn="c"/>
+            <a:r>
+              <a:rPr lang="en-US" sz="2000">
                 <a:solidFill>
                   <a:srgbClr val="5F6B7A"/>
                 </a:solidFill>
@@ -2696,9 +2186,9 @@
             </a:r>
           </a:p>
           <a:p>
-            <a:pPr algn="l"/>
-            <a:r>
-              <a:rPr lang="en-US" dirty="0">
+            <a:pPr algn="c"/>
+            <a:r>
+              <a:rPr lang="en-US" sz="2000">
                 <a:solidFill>
                   <a:srgbClr val="5F6B7A"/>
                 </a:solidFill>
@@ -2717,8 +2207,8 @@
         </p:nvSpPr>
         <p:spPr>
           <a:xfrm>
-            <a:off x="5849629" y="3638557"/>
-            <a:ext cx="366359" cy="304792"/>
+            <a:off x="5876925" y="3619500"/>
+            <a:ext cx="523875" cy="323850"/>
           </a:xfrm>
           <a:prstGeom prst="rightArrow">
             <a:avLst/>
@@ -2733,9 +2223,7 @@
         <p:txBody>
           <a:bodyPr/>
           <a:lstStyle/>
-          <a:p>
-            <a:endParaRPr/>
-          </a:p>
+          <a:p/>
         </p:txBody>
       </p:sp>
       <p:sp>
@@ -2764,9 +2252,7 @@
         <p:txBody>
           <a:bodyPr/>
           <a:lstStyle/>
-          <a:p>
-            <a:endParaRPr/>
-          </a:p>
+          <a:p/>
         </p:txBody>
       </p:sp>
       <p:sp>
@@ -2794,7 +2280,7 @@
           </a:bodyPr>
           <a:lstStyle/>
           <a:p>
-            <a:pPr algn="l"/>
+            <a:pPr algn="c"/>
             <a:r>
               <a:rPr lang="en-US" sz="2000" b="1">
                 <a:solidFill>
@@ -2816,25 +2302,25 @@
         <p:spPr>
           <a:xfrm>
             <a:off x="6438900" y="3933825"/>
-            <a:ext cx="1981200" cy="646331"/>
-          </a:xfrm>
-          <a:prstGeom prst="rect">
-            <a:avLst/>
-          </a:prstGeom>
-          <a:noFill/>
-          <a:ln>
-            <a:noFill/>
-          </a:ln>
-        </p:spPr>
-        <p:txBody>
-          <a:bodyPr wrap="square" anchor="t">
-            <a:spAutoFit/>
-          </a:bodyPr>
-          <a:lstStyle/>
-          <a:p>
-            <a:pPr algn="l"/>
-            <a:r>
-              <a:rPr lang="en-US" dirty="0">
+            <a:ext cx="1981200" cy="533400"/>
+          </a:xfrm>
+          <a:prstGeom prst="rect">
+            <a:avLst/>
+          </a:prstGeom>
+          <a:noFill/>
+          <a:ln>
+            <a:noFill/>
+          </a:ln>
+        </p:spPr>
+        <p:txBody>
+          <a:bodyPr wrap="square" anchor="t">
+            <a:spAutoFit/>
+          </a:bodyPr>
+          <a:lstStyle/>
+          <a:p>
+            <a:pPr algn="c"/>
+            <a:r>
+              <a:rPr lang="en-US" sz="2000">
                 <a:solidFill>
                   <a:srgbClr val="5F6B7A"/>
                 </a:solidFill>
@@ -2844,9 +2330,9 @@
             </a:r>
           </a:p>
           <a:p>
-            <a:pPr algn="l"/>
-            <a:r>
-              <a:rPr lang="en-US" dirty="0">
+            <a:pPr algn="c"/>
+            <a:r>
+              <a:rPr lang="en-US" sz="2000">
                 <a:solidFill>
                   <a:srgbClr val="5F6B7A"/>
                 </a:solidFill>
@@ -2865,8 +2351,8 @@
         </p:nvSpPr>
         <p:spPr>
           <a:xfrm>
-            <a:off x="8659504" y="3638557"/>
-            <a:ext cx="366359" cy="304792"/>
+            <a:off x="8686800" y="3619500"/>
+            <a:ext cx="523875" cy="323850"/>
           </a:xfrm>
           <a:prstGeom prst="rightArrow">
             <a:avLst/>
@@ -2881,9 +2367,7 @@
         <p:txBody>
           <a:bodyPr/>
           <a:lstStyle/>
-          <a:p>
-            <a:endParaRPr/>
-          </a:p>
+          <a:p/>
         </p:txBody>
       </p:sp>
       <p:sp>
@@ -2912,9 +2396,7 @@
         <p:txBody>
           <a:bodyPr/>
           <a:lstStyle/>
-          <a:p>
-            <a:endParaRPr/>
-          </a:p>
+          <a:p/>
         </p:txBody>
       </p:sp>
       <p:sp>
@@ -2942,7 +2424,7 @@
           </a:bodyPr>
           <a:lstStyle/>
           <a:p>
-            <a:pPr algn="l"/>
+            <a:pPr algn="c"/>
             <a:r>
               <a:rPr lang="en-US" sz="2000" b="1">
                 <a:solidFill>
@@ -2964,25 +2446,25 @@
         <p:spPr>
           <a:xfrm>
             <a:off x="9248775" y="3933825"/>
-            <a:ext cx="1981200" cy="646331"/>
-          </a:xfrm>
-          <a:prstGeom prst="rect">
-            <a:avLst/>
-          </a:prstGeom>
-          <a:noFill/>
-          <a:ln>
-            <a:noFill/>
-          </a:ln>
-        </p:spPr>
-        <p:txBody>
-          <a:bodyPr wrap="square" anchor="t">
-            <a:spAutoFit/>
-          </a:bodyPr>
-          <a:lstStyle/>
-          <a:p>
-            <a:pPr algn="l"/>
-            <a:r>
-              <a:rPr lang="en-US">
+            <a:ext cx="1981200" cy="533400"/>
+          </a:xfrm>
+          <a:prstGeom prst="rect">
+            <a:avLst/>
+          </a:prstGeom>
+          <a:noFill/>
+          <a:ln>
+            <a:noFill/>
+          </a:ln>
+        </p:spPr>
+        <p:txBody>
+          <a:bodyPr wrap="square" anchor="t">
+            <a:spAutoFit/>
+          </a:bodyPr>
+          <a:lstStyle/>
+          <a:p>
+            <a:pPr algn="c"/>
+            <a:r>
+              <a:rPr lang="en-US" sz="2000">
                 <a:solidFill>
                   <a:srgbClr val="5F6B7A"/>
                 </a:solidFill>
@@ -2992,9 +2474,9 @@
             </a:r>
           </a:p>
           <a:p>
-            <a:pPr algn="l"/>
-            <a:r>
-              <a:rPr lang="en-US">
+            <a:pPr algn="c"/>
+            <a:r>
+              <a:rPr lang="en-US" sz="2000">
                 <a:solidFill>
                   <a:srgbClr val="5F6B7A"/>
                 </a:solidFill>
@@ -3029,9 +2511,7 @@
         <p:txBody>
           <a:bodyPr/>
           <a:lstStyle/>
-          <a:p>
-            <a:endParaRPr/>
-          </a:p>
+          <a:p/>
         </p:txBody>
       </p:sp>
       <p:sp>
@@ -3096,9 +2576,7 @@
         <p:txBody>
           <a:bodyPr/>
           <a:lstStyle/>
-          <a:p>
-            <a:endParaRPr/>
-          </a:p>
+          <a:p/>
         </p:txBody>
       </p:sp>
       <p:sp>
@@ -3163,9 +2641,7 @@
         <p:txBody>
           <a:bodyPr/>
           <a:lstStyle/>
-          <a:p>
-            <a:endParaRPr/>
-          </a:p>
+          <a:p/>
         </p:txBody>
       </p:sp>
       <p:sp>
@@ -3222,7 +2698,6 @@
         <a:solidFill>
           <a:srgbClr val="F7F9FC"/>
         </a:solidFill>
-        <a:effectLst/>
       </p:bgPr>
     </p:bg>
     <p:spTree>
@@ -3342,7 +2817,7 @@
           <a:p>
             <a:pPr algn="l"/>
             <a:r>
-              <a:rPr lang="en-US" sz="2000" dirty="0">
+              <a:rPr lang="en-US" sz="2000">
                 <a:solidFill>
                   <a:srgbClr val="5F6B7A"/>
                 </a:solidFill>
@@ -3427,9 +2902,7 @@
         <p:txBody>
           <a:bodyPr/>
           <a:lstStyle/>
-          <a:p>
-            <a:endParaRPr/>
-          </a:p>
+          <a:p/>
         </p:txBody>
       </p:sp>
       <p:sp>
@@ -3494,9 +2967,7 @@
         <p:txBody>
           <a:bodyPr/>
           <a:lstStyle/>
-          <a:p>
-            <a:endParaRPr/>
-          </a:p>
+          <a:p/>
         </p:txBody>
       </p:sp>
       <p:sp>
@@ -3561,9 +3032,7 @@
         <p:txBody>
           <a:bodyPr/>
           <a:lstStyle/>
-          <a:p>
-            <a:endParaRPr/>
-          </a:p>
+          <a:p/>
         </p:txBody>
       </p:sp>
       <p:sp>
@@ -3620,7 +3089,6 @@
         <a:solidFill>
           <a:srgbClr val="F7F9FC"/>
         </a:solidFill>
-        <a:effectLst/>
       </p:bgPr>
     </p:bg>
     <p:spTree>
@@ -3772,45 +3240,113 @@
           </a:ln>
         </p:spPr>
       </p:cxnSp>
-      <p:pic>
-        <p:nvPicPr>
-          <p:cNvPr id="230" name="Sample size chart"/>
-          <p:cNvPicPr>
-            <a:picLocks noChangeAspect="1"/>
-          </p:cNvPicPr>
-          <p:nvPr/>
-        </p:nvPicPr>
-        <p:blipFill>
-          <a:blip r:embed="rId3"/>
-          <a:stretch>
-            <a:fillRect/>
-          </a:stretch>
-        </p:blipFill>
-        <p:spPr>
-          <a:xfrm>
-            <a:off x="4857750" y="2619375"/>
-            <a:ext cx="6572250" cy="3619500"/>
-          </a:xfrm>
-          <a:prstGeom prst="rect">
-            <a:avLst/>
-          </a:prstGeom>
-          <a:ln w="6000">
+      <p:sp>
+        <p:nvSpPr>
+          <p:cNvPr id="230" name="Text"/>
+          <p:cNvSpPr txBox="1"/>
+          <p:nvPr/>
+        </p:nvSpPr>
+        <p:spPr>
+          <a:xfrm>
+            <a:off x="4905375" y="2714625"/>
+            <a:ext cx="6191250" cy="266700"/>
+          </a:xfrm>
+          <a:prstGeom prst="rect">
+            <a:avLst/>
+          </a:prstGeom>
+          <a:noFill/>
+          <a:ln>
+            <a:noFill/>
+          </a:ln>
+        </p:spPr>
+        <p:txBody>
+          <a:bodyPr wrap="square" anchor="t">
+            <a:spAutoFit/>
+          </a:bodyPr>
+          <a:lstStyle/>
+          <a:p>
+            <a:pPr algn="l"/>
+            <a:r>
+              <a:rPr lang="en-US" sz="2000" b="1">
+                <a:solidFill>
+                  <a:srgbClr val="1F2933"/>
+                </a:solidFill>
+                <a:latin typeface="Arial"/>
+              </a:rPr>
+              <a:t>Modeled sessions by campaign</a:t>
+            </a:r>
+          </a:p>
+        </p:txBody>
+      </p:sp>
+      <p:cxnSp>
+        <p:nvCxnSpPr>
+          <p:cNvPr id="231" name="Line"/>
+          <p:cNvCxnSpPr/>
+          <p:nvPr/>
+        </p:nvCxnSpPr>
+        <p:spPr>
+          <a:xfrm>
+            <a:off x="4905375" y="3114675"/>
+            <a:ext cx="6191250" cy="1"/>
+          </a:xfrm>
+          <a:prstGeom prst="line">
+            <a:avLst/>
+          </a:prstGeom>
+          <a:ln w="18000">
             <a:solidFill>
               <a:srgbClr val="D8DEE6"/>
             </a:solidFill>
           </a:ln>
         </p:spPr>
-      </p:pic>
-      <p:sp>
-        <p:nvSpPr>
-          <p:cNvPr id="240" name="Rectangle"/>
+      </p:cxnSp>
+      <p:sp>
+        <p:nvSpPr>
+          <p:cNvPr id="240" name="Text"/>
+          <p:cNvSpPr txBox="1"/>
+          <p:nvPr/>
+        </p:nvSpPr>
+        <p:spPr>
+          <a:xfrm>
+            <a:off x="4905375" y="3267075"/>
+            <a:ext cx="2000250" cy="323850"/>
+          </a:xfrm>
+          <a:prstGeom prst="rect">
+            <a:avLst/>
+          </a:prstGeom>
+          <a:noFill/>
+          <a:ln>
+            <a:noFill/>
+          </a:ln>
+        </p:spPr>
+        <p:txBody>
+          <a:bodyPr wrap="square" anchor="t">
+            <a:spAutoFit/>
+          </a:bodyPr>
+          <a:lstStyle/>
+          <a:p>
+            <a:pPr algn="r"/>
+            <a:r>
+              <a:rPr lang="en-US" sz="2000">
+                <a:solidFill>
+                  <a:srgbClr val="1F2933"/>
+                </a:solidFill>
+                <a:latin typeface="Arial"/>
+              </a:rPr>
+              <a:t>Organic</a:t>
+            </a:r>
+          </a:p>
+        </p:txBody>
+      </p:sp>
+      <p:sp>
+        <p:nvSpPr>
+          <p:cNvPr id="241" name="Rectangle"/>
           <p:cNvSpPr/>
           <p:nvPr/>
         </p:nvSpPr>
         <p:spPr>
           <a:xfrm>
-            <a:off x="904875" y="2933700"/>
-            <a:ext cx="114300" cy="114300"/>
+            <a:off x="7077075" y="3324225"/>
+            <a:ext cx="2428875" cy="209550"/>
           </a:xfrm>
           <a:prstGeom prst="roundRect">
             <a:avLst/>
@@ -3825,59 +3361,95 @@
         <p:txBody>
           <a:bodyPr/>
           <a:lstStyle/>
-          <a:p>
-            <a:endParaRPr/>
-          </a:p>
-        </p:txBody>
-      </p:sp>
-      <p:sp>
-        <p:nvSpPr>
-          <p:cNvPr id="241" name="Text"/>
-          <p:cNvSpPr txBox="1"/>
-          <p:nvPr/>
-        </p:nvSpPr>
-        <p:spPr>
-          <a:xfrm>
-            <a:off x="1171575" y="2857500"/>
-            <a:ext cx="3314700" cy="428625"/>
-          </a:xfrm>
-          <a:prstGeom prst="rect">
-            <a:avLst/>
-          </a:prstGeom>
-          <a:noFill/>
-          <a:ln>
-            <a:noFill/>
-          </a:ln>
-        </p:spPr>
-        <p:txBody>
-          <a:bodyPr wrap="square" anchor="t">
-            <a:spAutoFit/>
-          </a:bodyPr>
-          <a:lstStyle/>
-          <a:p>
-            <a:pPr algn="l"/>
-            <a:r>
-              <a:rPr lang="en-US" sz="2000">
-                <a:solidFill>
-                  <a:srgbClr val="1F2933"/>
-                </a:solidFill>
-                <a:latin typeface="Arial"/>
-              </a:rPr>
-              <a:t>Organic: 102,309 modeled sessions.</a:t>
-            </a:r>
-          </a:p>
-        </p:txBody>
-      </p:sp>
-      <p:sp>
-        <p:nvSpPr>
-          <p:cNvPr id="243" name="Rectangle"/>
+          <a:p/>
+        </p:txBody>
+      </p:sp>
+      <p:sp>
+        <p:nvSpPr>
+          <p:cNvPr id="242" name="Text"/>
+          <p:cNvSpPr txBox="1"/>
+          <p:nvPr/>
+        </p:nvSpPr>
+        <p:spPr>
+          <a:xfrm>
+            <a:off x="9601200" y="3267075"/>
+            <a:ext cx="1381125" cy="323850"/>
+          </a:xfrm>
+          <a:prstGeom prst="rect">
+            <a:avLst/>
+          </a:prstGeom>
+          <a:noFill/>
+          <a:ln>
+            <a:noFill/>
+          </a:ln>
+        </p:spPr>
+        <p:txBody>
+          <a:bodyPr wrap="square" anchor="t">
+            <a:spAutoFit/>
+          </a:bodyPr>
+          <a:lstStyle/>
+          <a:p>
+            <a:pPr algn="l"/>
+            <a:r>
+              <a:rPr lang="en-US" sz="2000">
+                <a:solidFill>
+                  <a:srgbClr val="1F2933"/>
+                </a:solidFill>
+                <a:latin typeface="Arial"/>
+              </a:rPr>
+              <a:t>102,309</a:t>
+            </a:r>
+          </a:p>
+        </p:txBody>
+      </p:sp>
+      <p:sp>
+        <p:nvSpPr>
+          <p:cNvPr id="245" name="Text"/>
+          <p:cNvSpPr txBox="1"/>
+          <p:nvPr/>
+        </p:nvSpPr>
+        <p:spPr>
+          <a:xfrm>
+            <a:off x="4905375" y="3743325"/>
+            <a:ext cx="2000250" cy="323850"/>
+          </a:xfrm>
+          <a:prstGeom prst="rect">
+            <a:avLst/>
+          </a:prstGeom>
+          <a:noFill/>
+          <a:ln>
+            <a:noFill/>
+          </a:ln>
+        </p:spPr>
+        <p:txBody>
+          <a:bodyPr wrap="square" anchor="t">
+            <a:spAutoFit/>
+          </a:bodyPr>
+          <a:lstStyle/>
+          <a:p>
+            <a:pPr algn="r"/>
+            <a:r>
+              <a:rPr lang="en-US" sz="2000">
+                <a:solidFill>
+                  <a:srgbClr val="1F2933"/>
+                </a:solidFill>
+                <a:latin typeface="Arial"/>
+              </a:rPr>
+              <a:t>Referral</a:t>
+            </a:r>
+          </a:p>
+        </p:txBody>
+      </p:sp>
+      <p:sp>
+        <p:nvSpPr>
+          <p:cNvPr id="246" name="Rectangle"/>
           <p:cNvSpPr/>
           <p:nvPr/>
         </p:nvSpPr>
         <p:spPr>
           <a:xfrm>
-            <a:off x="904875" y="3467100"/>
-            <a:ext cx="114300" cy="114300"/>
+            <a:off x="7077075" y="3800475"/>
+            <a:ext cx="2383188" cy="209550"/>
           </a:xfrm>
           <a:prstGeom prst="roundRect">
             <a:avLst/>
@@ -3892,59 +3464,95 @@
         <p:txBody>
           <a:bodyPr/>
           <a:lstStyle/>
-          <a:p>
-            <a:endParaRPr/>
-          </a:p>
-        </p:txBody>
-      </p:sp>
-      <p:sp>
-        <p:nvSpPr>
-          <p:cNvPr id="244" name="Text"/>
-          <p:cNvSpPr txBox="1"/>
-          <p:nvPr/>
-        </p:nvSpPr>
-        <p:spPr>
-          <a:xfrm>
-            <a:off x="1171575" y="3390900"/>
-            <a:ext cx="3314700" cy="428625"/>
-          </a:xfrm>
-          <a:prstGeom prst="rect">
-            <a:avLst/>
-          </a:prstGeom>
-          <a:noFill/>
-          <a:ln>
-            <a:noFill/>
-          </a:ln>
-        </p:spPr>
-        <p:txBody>
-          <a:bodyPr wrap="square" anchor="t">
-            <a:spAutoFit/>
-          </a:bodyPr>
-          <a:lstStyle/>
-          <a:p>
-            <a:pPr algn="l"/>
-            <a:r>
-              <a:rPr lang="en-US" sz="2000">
-                <a:solidFill>
-                  <a:srgbClr val="1F2933"/>
-                </a:solidFill>
-                <a:latin typeface="Arial"/>
-              </a:rPr>
-              <a:t>Referral: 82,353 modeled sessions.</a:t>
-            </a:r>
-          </a:p>
-        </p:txBody>
-      </p:sp>
-      <p:sp>
-        <p:nvSpPr>
-          <p:cNvPr id="246" name="Rectangle"/>
+          <a:p/>
+        </p:txBody>
+      </p:sp>
+      <p:sp>
+        <p:nvSpPr>
+          <p:cNvPr id="247" name="Text"/>
+          <p:cNvSpPr txBox="1"/>
+          <p:nvPr/>
+        </p:nvSpPr>
+        <p:spPr>
+          <a:xfrm>
+            <a:off x="9555513" y="3743325"/>
+            <a:ext cx="1381125" cy="323850"/>
+          </a:xfrm>
+          <a:prstGeom prst="rect">
+            <a:avLst/>
+          </a:prstGeom>
+          <a:noFill/>
+          <a:ln>
+            <a:noFill/>
+          </a:ln>
+        </p:spPr>
+        <p:txBody>
+          <a:bodyPr wrap="square" anchor="t">
+            <a:spAutoFit/>
+          </a:bodyPr>
+          <a:lstStyle/>
+          <a:p>
+            <a:pPr algn="l"/>
+            <a:r>
+              <a:rPr lang="en-US" sz="2000">
+                <a:solidFill>
+                  <a:srgbClr val="1F2933"/>
+                </a:solidFill>
+                <a:latin typeface="Arial"/>
+              </a:rPr>
+              <a:t>82,353</a:t>
+            </a:r>
+          </a:p>
+        </p:txBody>
+      </p:sp>
+      <p:sp>
+        <p:nvSpPr>
+          <p:cNvPr id="250" name="Text"/>
+          <p:cNvSpPr txBox="1"/>
+          <p:nvPr/>
+        </p:nvSpPr>
+        <p:spPr>
+          <a:xfrm>
+            <a:off x="4905375" y="4219575"/>
+            <a:ext cx="2000250" cy="323850"/>
+          </a:xfrm>
+          <a:prstGeom prst="rect">
+            <a:avLst/>
+          </a:prstGeom>
+          <a:noFill/>
+          <a:ln>
+            <a:noFill/>
+          </a:ln>
+        </p:spPr>
+        <p:txBody>
+          <a:bodyPr wrap="square" anchor="t">
+            <a:spAutoFit/>
+          </a:bodyPr>
+          <a:lstStyle/>
+          <a:p>
+            <a:pPr algn="r"/>
+            <a:r>
+              <a:rPr lang="en-US" sz="2000">
+                <a:solidFill>
+                  <a:srgbClr val="1F2933"/>
+                </a:solidFill>
+                <a:latin typeface="Arial"/>
+              </a:rPr>
+              <a:t>Other</a:t>
+            </a:r>
+          </a:p>
+        </p:txBody>
+      </p:sp>
+      <p:sp>
+        <p:nvSpPr>
+          <p:cNvPr id="251" name="Rectangle"/>
           <p:cNvSpPr/>
           <p:nvPr/>
         </p:nvSpPr>
         <p:spPr>
           <a:xfrm>
-            <a:off x="904875" y="4000500"/>
-            <a:ext cx="114300" cy="114300"/>
+            <a:off x="7077075" y="4276725"/>
+            <a:ext cx="2190784" cy="209550"/>
           </a:xfrm>
           <a:prstGeom prst="roundRect">
             <a:avLst/>
@@ -3959,58 +3567,365 @@
         <p:txBody>
           <a:bodyPr/>
           <a:lstStyle/>
-          <a:p>
-            <a:endParaRPr/>
-          </a:p>
-        </p:txBody>
-      </p:sp>
-      <p:sp>
-        <p:nvSpPr>
-          <p:cNvPr id="247" name="Text"/>
-          <p:cNvSpPr txBox="1"/>
-          <p:nvPr/>
-        </p:nvSpPr>
-        <p:spPr>
-          <a:xfrm>
-            <a:off x="1171575" y="3924300"/>
-            <a:ext cx="3314700" cy="428625"/>
-          </a:xfrm>
-          <a:prstGeom prst="rect">
-            <a:avLst/>
-          </a:prstGeom>
-          <a:noFill/>
-          <a:ln>
-            <a:noFill/>
-          </a:ln>
-        </p:spPr>
-        <p:txBody>
-          <a:bodyPr wrap="square" anchor="t">
-            <a:spAutoFit/>
-          </a:bodyPr>
-          <a:lstStyle/>
-          <a:p>
-            <a:pPr algn="l"/>
-            <a:r>
-              <a:rPr lang="en-US" sz="2000">
-                <a:solidFill>
-                  <a:srgbClr val="1F2933"/>
-                </a:solidFill>
-                <a:latin typeface="Arial"/>
-              </a:rPr>
-              <a:t>Data Share Promo: 1,294 modeled sessions.</a:t>
-            </a:r>
-          </a:p>
-        </p:txBody>
-      </p:sp>
-      <p:sp>
-        <p:nvSpPr>
-          <p:cNvPr id="249" name="Rectangle"/>
+          <a:p/>
+        </p:txBody>
+      </p:sp>
+      <p:sp>
+        <p:nvSpPr>
+          <p:cNvPr id="252" name="Text"/>
+          <p:cNvSpPr txBox="1"/>
+          <p:nvPr/>
+        </p:nvSpPr>
+        <p:spPr>
+          <a:xfrm>
+            <a:off x="9363109" y="4219575"/>
+            <a:ext cx="1381125" cy="323850"/>
+          </a:xfrm>
+          <a:prstGeom prst="rect">
+            <a:avLst/>
+          </a:prstGeom>
+          <a:noFill/>
+          <a:ln>
+            <a:noFill/>
+          </a:ln>
+        </p:spPr>
+        <p:txBody>
+          <a:bodyPr wrap="square" anchor="t">
+            <a:spAutoFit/>
+          </a:bodyPr>
+          <a:lstStyle/>
+          <a:p>
+            <a:pPr algn="l"/>
+            <a:r>
+              <a:rPr lang="en-US" sz="2000">
+                <a:solidFill>
+                  <a:srgbClr val="1F2933"/>
+                </a:solidFill>
+                <a:latin typeface="Arial"/>
+              </a:rPr>
+              <a:t>33,023</a:t>
+            </a:r>
+          </a:p>
+        </p:txBody>
+      </p:sp>
+      <p:sp>
+        <p:nvSpPr>
+          <p:cNvPr id="255" name="Text"/>
+          <p:cNvSpPr txBox="1"/>
+          <p:nvPr/>
+        </p:nvSpPr>
+        <p:spPr>
+          <a:xfrm>
+            <a:off x="4905375" y="4695825"/>
+            <a:ext cx="2000250" cy="323850"/>
+          </a:xfrm>
+          <a:prstGeom prst="rect">
+            <a:avLst/>
+          </a:prstGeom>
+          <a:noFill/>
+          <a:ln>
+            <a:noFill/>
+          </a:ln>
+        </p:spPr>
+        <p:txBody>
+          <a:bodyPr wrap="square" anchor="t">
+            <a:spAutoFit/>
+          </a:bodyPr>
+          <a:lstStyle/>
+          <a:p>
+            <a:pPr algn="r"/>
+            <a:r>
+              <a:rPr lang="en-US" sz="2000">
+                <a:solidFill>
+                  <a:srgbClr val="1F2933"/>
+                </a:solidFill>
+                <a:latin typeface="Arial"/>
+              </a:rPr>
+              <a:t>Data Share</a:t>
+            </a:r>
+          </a:p>
+        </p:txBody>
+      </p:sp>
+      <p:sp>
+        <p:nvSpPr>
+          <p:cNvPr id="256" name="Rectangle"/>
           <p:cNvSpPr/>
           <p:nvPr/>
         </p:nvSpPr>
         <p:spPr>
           <a:xfrm>
-            <a:off x="904875" y="4533900"/>
+            <a:off x="7077075" y="4752975"/>
+            <a:ext cx="1508708" cy="209550"/>
+          </a:xfrm>
+          <a:prstGeom prst="roundRect">
+            <a:avLst/>
+          </a:prstGeom>
+          <a:solidFill>
+            <a:srgbClr val="F57C00"/>
+          </a:solidFill>
+          <a:ln>
+            <a:noFill/>
+          </a:ln>
+        </p:spPr>
+        <p:txBody>
+          <a:bodyPr/>
+          <a:lstStyle/>
+          <a:p/>
+        </p:txBody>
+      </p:sp>
+      <p:sp>
+        <p:nvSpPr>
+          <p:cNvPr id="257" name="Text"/>
+          <p:cNvSpPr txBox="1"/>
+          <p:nvPr/>
+        </p:nvSpPr>
+        <p:spPr>
+          <a:xfrm>
+            <a:off x="8681033" y="4695825"/>
+            <a:ext cx="1381125" cy="323850"/>
+          </a:xfrm>
+          <a:prstGeom prst="rect">
+            <a:avLst/>
+          </a:prstGeom>
+          <a:noFill/>
+          <a:ln>
+            <a:noFill/>
+          </a:ln>
+        </p:spPr>
+        <p:txBody>
+          <a:bodyPr wrap="square" anchor="t">
+            <a:spAutoFit/>
+          </a:bodyPr>
+          <a:lstStyle/>
+          <a:p>
+            <a:pPr algn="l"/>
+            <a:r>
+              <a:rPr lang="en-US" sz="2000">
+                <a:solidFill>
+                  <a:srgbClr val="1F2933"/>
+                </a:solidFill>
+                <a:latin typeface="Arial"/>
+              </a:rPr>
+              <a:t>1,294</a:t>
+            </a:r>
+          </a:p>
+        </p:txBody>
+      </p:sp>
+      <p:sp>
+        <p:nvSpPr>
+          <p:cNvPr id="260" name="Text"/>
+          <p:cNvSpPr txBox="1"/>
+          <p:nvPr/>
+        </p:nvSpPr>
+        <p:spPr>
+          <a:xfrm>
+            <a:off x="4905375" y="5172075"/>
+            <a:ext cx="2000250" cy="323850"/>
+          </a:xfrm>
+          <a:prstGeom prst="rect">
+            <a:avLst/>
+          </a:prstGeom>
+          <a:noFill/>
+          <a:ln>
+            <a:noFill/>
+          </a:ln>
+        </p:spPr>
+        <p:txBody>
+          <a:bodyPr wrap="square" anchor="t">
+            <a:spAutoFit/>
+          </a:bodyPr>
+          <a:lstStyle/>
+          <a:p>
+            <a:pPr algn="r"/>
+            <a:r>
+              <a:rPr lang="en-US" sz="2000">
+                <a:solidFill>
+                  <a:srgbClr val="1F2933"/>
+                </a:solidFill>
+                <a:latin typeface="Arial"/>
+              </a:rPr>
+              <a:t>NewYear V1</a:t>
+            </a:r>
+          </a:p>
+        </p:txBody>
+      </p:sp>
+      <p:sp>
+        <p:nvSpPr>
+          <p:cNvPr id="261" name="Rectangle"/>
+          <p:cNvSpPr/>
+          <p:nvPr/>
+        </p:nvSpPr>
+        <p:spPr>
+          <a:xfrm>
+            <a:off x="7077075" y="5229225"/>
+            <a:ext cx="882139" cy="209550"/>
+          </a:xfrm>
+          <a:prstGeom prst="roundRect">
+            <a:avLst/>
+          </a:prstGeom>
+          <a:solidFill>
+            <a:srgbClr val="F57C00"/>
+          </a:solidFill>
+          <a:ln>
+            <a:noFill/>
+          </a:ln>
+        </p:spPr>
+        <p:txBody>
+          <a:bodyPr/>
+          <a:lstStyle/>
+          <a:p/>
+        </p:txBody>
+      </p:sp>
+      <p:sp>
+        <p:nvSpPr>
+          <p:cNvPr id="262" name="Text"/>
+          <p:cNvSpPr txBox="1"/>
+          <p:nvPr/>
+        </p:nvSpPr>
+        <p:spPr>
+          <a:xfrm>
+            <a:off x="8054464" y="5172075"/>
+            <a:ext cx="1381125" cy="323850"/>
+          </a:xfrm>
+          <a:prstGeom prst="rect">
+            <a:avLst/>
+          </a:prstGeom>
+          <a:noFill/>
+          <a:ln>
+            <a:noFill/>
+          </a:ln>
+        </p:spPr>
+        <p:txBody>
+          <a:bodyPr wrap="square" anchor="t">
+            <a:spAutoFit/>
+          </a:bodyPr>
+          <a:lstStyle/>
+          <a:p>
+            <a:pPr algn="l"/>
+            <a:r>
+              <a:rPr lang="en-US" sz="2000">
+                <a:solidFill>
+                  <a:srgbClr val="1F2933"/>
+                </a:solidFill>
+                <a:latin typeface="Arial"/>
+              </a:rPr>
+              <a:t>66</a:t>
+            </a:r>
+          </a:p>
+        </p:txBody>
+      </p:sp>
+      <p:sp>
+        <p:nvSpPr>
+          <p:cNvPr id="265" name="Text"/>
+          <p:cNvSpPr txBox="1"/>
+          <p:nvPr/>
+        </p:nvSpPr>
+        <p:spPr>
+          <a:xfrm>
+            <a:off x="4905375" y="5648325"/>
+            <a:ext cx="2000250" cy="323850"/>
+          </a:xfrm>
+          <a:prstGeom prst="rect">
+            <a:avLst/>
+          </a:prstGeom>
+          <a:noFill/>
+          <a:ln>
+            <a:noFill/>
+          </a:ln>
+        </p:spPr>
+        <p:txBody>
+          <a:bodyPr wrap="square" anchor="t">
+            <a:spAutoFit/>
+          </a:bodyPr>
+          <a:lstStyle/>
+          <a:p>
+            <a:pPr algn="r"/>
+            <a:r>
+              <a:rPr lang="en-US" sz="2000">
+                <a:solidFill>
+                  <a:srgbClr val="1F2933"/>
+                </a:solidFill>
+                <a:latin typeface="Arial"/>
+              </a:rPr>
+              <a:t>NewYear V2</a:t>
+            </a:r>
+          </a:p>
+        </p:txBody>
+      </p:sp>
+      <p:sp>
+        <p:nvSpPr>
+          <p:cNvPr id="266" name="Rectangle"/>
+          <p:cNvSpPr/>
+          <p:nvPr/>
+        </p:nvSpPr>
+        <p:spPr>
+          <a:xfrm>
+            <a:off x="7077075" y="5705475"/>
+            <a:ext cx="771369" cy="209550"/>
+          </a:xfrm>
+          <a:prstGeom prst="roundRect">
+            <a:avLst/>
+          </a:prstGeom>
+          <a:solidFill>
+            <a:srgbClr val="F57C00"/>
+          </a:solidFill>
+          <a:ln>
+            <a:noFill/>
+          </a:ln>
+        </p:spPr>
+        <p:txBody>
+          <a:bodyPr/>
+          <a:lstStyle/>
+          <a:p/>
+        </p:txBody>
+      </p:sp>
+      <p:sp>
+        <p:nvSpPr>
+          <p:cNvPr id="267" name="Text"/>
+          <p:cNvSpPr txBox="1"/>
+          <p:nvPr/>
+        </p:nvSpPr>
+        <p:spPr>
+          <a:xfrm>
+            <a:off x="7943694" y="5648325"/>
+            <a:ext cx="1381125" cy="323850"/>
+          </a:xfrm>
+          <a:prstGeom prst="rect">
+            <a:avLst/>
+          </a:prstGeom>
+          <a:noFill/>
+          <a:ln>
+            <a:noFill/>
+          </a:ln>
+        </p:spPr>
+        <p:txBody>
+          <a:bodyPr wrap="square" anchor="t">
+            <a:spAutoFit/>
+          </a:bodyPr>
+          <a:lstStyle/>
+          <a:p>
+            <a:pPr algn="l"/>
+            <a:r>
+              <a:rPr lang="en-US" sz="2000">
+                <a:solidFill>
+                  <a:srgbClr val="1F2933"/>
+                </a:solidFill>
+                <a:latin typeface="Arial"/>
+              </a:rPr>
+              <a:t>39</a:t>
+            </a:r>
+          </a:p>
+        </p:txBody>
+      </p:sp>
+      <p:sp>
+        <p:nvSpPr>
+          <p:cNvPr id="330" name="Rectangle"/>
+          <p:cNvSpPr/>
+          <p:nvPr/>
+        </p:nvSpPr>
+        <p:spPr>
+          <a:xfrm>
+            <a:off x="904875" y="2933700"/>
             <a:ext cx="114300" cy="114300"/>
           </a:xfrm>
           <a:prstGeom prst="roundRect">
@@ -4026,14 +3941,207 @@
         <p:txBody>
           <a:bodyPr/>
           <a:lstStyle/>
-          <a:p>
-            <a:endParaRPr/>
-          </a:p>
-        </p:txBody>
-      </p:sp>
-      <p:sp>
-        <p:nvSpPr>
-          <p:cNvPr id="250" name="Text"/>
+          <a:p/>
+        </p:txBody>
+      </p:sp>
+      <p:sp>
+        <p:nvSpPr>
+          <p:cNvPr id="331" name="Text"/>
+          <p:cNvSpPr txBox="1"/>
+          <p:nvPr/>
+        </p:nvSpPr>
+        <p:spPr>
+          <a:xfrm>
+            <a:off x="1171575" y="2857500"/>
+            <a:ext cx="3314700" cy="428625"/>
+          </a:xfrm>
+          <a:prstGeom prst="rect">
+            <a:avLst/>
+          </a:prstGeom>
+          <a:noFill/>
+          <a:ln>
+            <a:noFill/>
+          </a:ln>
+        </p:spPr>
+        <p:txBody>
+          <a:bodyPr wrap="square" anchor="t">
+            <a:spAutoFit/>
+          </a:bodyPr>
+          <a:lstStyle/>
+          <a:p>
+            <a:pPr algn="l"/>
+            <a:r>
+              <a:rPr lang="en-US" sz="2000">
+                <a:solidFill>
+                  <a:srgbClr val="1F2933"/>
+                </a:solidFill>
+                <a:latin typeface="Arial"/>
+              </a:rPr>
+              <a:t>Organic: 102,309 modeled sessions.</a:t>
+            </a:r>
+          </a:p>
+        </p:txBody>
+      </p:sp>
+      <p:sp>
+        <p:nvSpPr>
+          <p:cNvPr id="333" name="Rectangle"/>
+          <p:cNvSpPr/>
+          <p:nvPr/>
+        </p:nvSpPr>
+        <p:spPr>
+          <a:xfrm>
+            <a:off x="904875" y="3467100"/>
+            <a:ext cx="114300" cy="114300"/>
+          </a:xfrm>
+          <a:prstGeom prst="roundRect">
+            <a:avLst/>
+          </a:prstGeom>
+          <a:solidFill>
+            <a:srgbClr val="1F77B4"/>
+          </a:solidFill>
+          <a:ln>
+            <a:noFill/>
+          </a:ln>
+        </p:spPr>
+        <p:txBody>
+          <a:bodyPr/>
+          <a:lstStyle/>
+          <a:p/>
+        </p:txBody>
+      </p:sp>
+      <p:sp>
+        <p:nvSpPr>
+          <p:cNvPr id="334" name="Text"/>
+          <p:cNvSpPr txBox="1"/>
+          <p:nvPr/>
+        </p:nvSpPr>
+        <p:spPr>
+          <a:xfrm>
+            <a:off x="1171575" y="3390900"/>
+            <a:ext cx="3314700" cy="428625"/>
+          </a:xfrm>
+          <a:prstGeom prst="rect">
+            <a:avLst/>
+          </a:prstGeom>
+          <a:noFill/>
+          <a:ln>
+            <a:noFill/>
+          </a:ln>
+        </p:spPr>
+        <p:txBody>
+          <a:bodyPr wrap="square" anchor="t">
+            <a:spAutoFit/>
+          </a:bodyPr>
+          <a:lstStyle/>
+          <a:p>
+            <a:pPr algn="l"/>
+            <a:r>
+              <a:rPr lang="en-US" sz="2000">
+                <a:solidFill>
+                  <a:srgbClr val="1F2933"/>
+                </a:solidFill>
+                <a:latin typeface="Arial"/>
+              </a:rPr>
+              <a:t>Referral: 82,353 modeled sessions.</a:t>
+            </a:r>
+          </a:p>
+        </p:txBody>
+      </p:sp>
+      <p:sp>
+        <p:nvSpPr>
+          <p:cNvPr id="336" name="Rectangle"/>
+          <p:cNvSpPr/>
+          <p:nvPr/>
+        </p:nvSpPr>
+        <p:spPr>
+          <a:xfrm>
+            <a:off x="904875" y="4000500"/>
+            <a:ext cx="114300" cy="114300"/>
+          </a:xfrm>
+          <a:prstGeom prst="roundRect">
+            <a:avLst/>
+          </a:prstGeom>
+          <a:solidFill>
+            <a:srgbClr val="1F77B4"/>
+          </a:solidFill>
+          <a:ln>
+            <a:noFill/>
+          </a:ln>
+        </p:spPr>
+        <p:txBody>
+          <a:bodyPr/>
+          <a:lstStyle/>
+          <a:p/>
+        </p:txBody>
+      </p:sp>
+      <p:sp>
+        <p:nvSpPr>
+          <p:cNvPr id="337" name="Text"/>
+          <p:cNvSpPr txBox="1"/>
+          <p:nvPr/>
+        </p:nvSpPr>
+        <p:spPr>
+          <a:xfrm>
+            <a:off x="1171575" y="3924300"/>
+            <a:ext cx="3314700" cy="428625"/>
+          </a:xfrm>
+          <a:prstGeom prst="rect">
+            <a:avLst/>
+          </a:prstGeom>
+          <a:noFill/>
+          <a:ln>
+            <a:noFill/>
+          </a:ln>
+        </p:spPr>
+        <p:txBody>
+          <a:bodyPr wrap="square" anchor="t">
+            <a:spAutoFit/>
+          </a:bodyPr>
+          <a:lstStyle/>
+          <a:p>
+            <a:pPr algn="l"/>
+            <a:r>
+              <a:rPr lang="en-US" sz="2000">
+                <a:solidFill>
+                  <a:srgbClr val="1F2933"/>
+                </a:solidFill>
+                <a:latin typeface="Arial"/>
+              </a:rPr>
+              <a:t>Data Share Promo: 1,294 modeled sessions.</a:t>
+            </a:r>
+          </a:p>
+        </p:txBody>
+      </p:sp>
+      <p:sp>
+        <p:nvSpPr>
+          <p:cNvPr id="339" name="Rectangle"/>
+          <p:cNvSpPr/>
+          <p:nvPr/>
+        </p:nvSpPr>
+        <p:spPr>
+          <a:xfrm>
+            <a:off x="904875" y="4533900"/>
+            <a:ext cx="114300" cy="114300"/>
+          </a:xfrm>
+          <a:prstGeom prst="roundRect">
+            <a:avLst/>
+          </a:prstGeom>
+          <a:solidFill>
+            <a:srgbClr val="1F77B4"/>
+          </a:solidFill>
+          <a:ln>
+            <a:noFill/>
+          </a:ln>
+        </p:spPr>
+        <p:txBody>
+          <a:bodyPr/>
+          <a:lstStyle/>
+          <a:p/>
+        </p:txBody>
+      </p:sp>
+      <p:sp>
+        <p:nvSpPr>
+          <p:cNvPr id="340" name="Text"/>
           <p:cNvSpPr txBox="1"/>
           <p:nvPr/>
         </p:nvSpPr>
@@ -4058,7 +4166,7 @@
           <a:p>
             <a:pPr algn="l"/>
             <a:r>
-              <a:rPr lang="en-US" sz="2000" dirty="0">
+              <a:rPr lang="en-US" sz="2000">
                 <a:solidFill>
                   <a:srgbClr val="1F2933"/>
                 </a:solidFill>
@@ -4085,7 +4193,6 @@
         <a:solidFill>
           <a:srgbClr val="F7F9FC"/>
         </a:solidFill>
-        <a:effectLst/>
       </p:bgPr>
     </p:bg>
     <p:spTree>
@@ -4237,45 +4344,765 @@
           </a:ln>
         </p:spPr>
       </p:cxnSp>
-      <p:pic>
-        <p:nvPicPr>
-          <p:cNvPr id="270" name="Top combinations chart"/>
-          <p:cNvPicPr>
-            <a:picLocks noChangeAspect="1"/>
-          </p:cNvPicPr>
-          <p:nvPr/>
-        </p:nvPicPr>
-        <p:blipFill>
-          <a:blip r:embed="rId3"/>
-          <a:stretch>
-            <a:fillRect/>
-          </a:stretch>
-        </p:blipFill>
-        <p:spPr>
-          <a:xfrm>
-            <a:off x="4619625" y="2476500"/>
-            <a:ext cx="7433510" cy="4279899"/>
-          </a:xfrm>
-          <a:prstGeom prst="rect">
-            <a:avLst/>
-          </a:prstGeom>
-          <a:ln w="6000">
+      <p:sp>
+        <p:nvSpPr>
+          <p:cNvPr id="270" name="Text"/>
+          <p:cNvSpPr txBox="1"/>
+          <p:nvPr/>
+        </p:nvSpPr>
+        <p:spPr>
+          <a:xfrm>
+            <a:off x="4905375" y="2714625"/>
+            <a:ext cx="6191250" cy="266700"/>
+          </a:xfrm>
+          <a:prstGeom prst="rect">
+            <a:avLst/>
+          </a:prstGeom>
+          <a:noFill/>
+          <a:ln>
+            <a:noFill/>
+          </a:ln>
+        </p:spPr>
+        <p:txBody>
+          <a:bodyPr wrap="square" anchor="t">
+            <a:spAutoFit/>
+          </a:bodyPr>
+          <a:lstStyle/>
+          <a:p>
+            <a:pPr algn="l"/>
+            <a:r>
+              <a:rPr lang="en-US" sz="2000" b="1">
+                <a:solidFill>
+                  <a:srgbClr val="1F2933"/>
+                </a:solidFill>
+                <a:latin typeface="Arial"/>
+              </a:rPr>
+              <a:t>Highest weekday averages</a:t>
+            </a:r>
+          </a:p>
+        </p:txBody>
+      </p:sp>
+      <p:cxnSp>
+        <p:nvCxnSpPr>
+          <p:cNvPr id="271" name="Line"/>
+          <p:cNvCxnSpPr/>
+          <p:nvPr/>
+        </p:nvCxnSpPr>
+        <p:spPr>
+          <a:xfrm>
+            <a:off x="4905375" y="3114675"/>
+            <a:ext cx="6191250" cy="1"/>
+          </a:xfrm>
+          <a:prstGeom prst="line">
+            <a:avLst/>
+          </a:prstGeom>
+          <a:ln w="18000">
             <a:solidFill>
               <a:srgbClr val="D8DEE6"/>
             </a:solidFill>
           </a:ln>
         </p:spPr>
-      </p:pic>
-      <p:sp>
-        <p:nvSpPr>
-          <p:cNvPr id="280" name="Rectangle"/>
+      </p:cxnSp>
+      <p:sp>
+        <p:nvSpPr>
+          <p:cNvPr id="280" name="Text"/>
+          <p:cNvSpPr txBox="1"/>
+          <p:nvPr/>
+        </p:nvSpPr>
+        <p:spPr>
+          <a:xfrm>
+            <a:off x="4905375" y="3267075"/>
+            <a:ext cx="2000250" cy="323850"/>
+          </a:xfrm>
+          <a:prstGeom prst="rect">
+            <a:avLst/>
+          </a:prstGeom>
+          <a:noFill/>
+          <a:ln>
+            <a:noFill/>
+          </a:ln>
+        </p:spPr>
+        <p:txBody>
+          <a:bodyPr wrap="square" anchor="t">
+            <a:spAutoFit/>
+          </a:bodyPr>
+          <a:lstStyle/>
+          <a:p>
+            <a:pPr algn="r"/>
+            <a:r>
+              <a:rPr lang="en-US" sz="2000">
+                <a:solidFill>
+                  <a:srgbClr val="1F2933"/>
+                </a:solidFill>
+                <a:latin typeface="Arial"/>
+              </a:rPr>
+              <a:t>BF V2 Sun</a:t>
+            </a:r>
+          </a:p>
+        </p:txBody>
+      </p:sp>
+      <p:sp>
+        <p:nvSpPr>
+          <p:cNvPr id="281" name="Rectangle"/>
           <p:cNvSpPr/>
           <p:nvPr/>
         </p:nvSpPr>
         <p:spPr>
           <a:xfrm>
-            <a:off x="904875" y="3000374"/>
-            <a:ext cx="3429000" cy="1485895"/>
+            <a:off x="7077075" y="3324225"/>
+            <a:ext cx="2428875" cy="171450"/>
+          </a:xfrm>
+          <a:prstGeom prst="roundRect">
+            <a:avLst/>
+          </a:prstGeom>
+          <a:solidFill>
+            <a:srgbClr val="7E57C2"/>
+          </a:solidFill>
+          <a:ln>
+            <a:noFill/>
+          </a:ln>
+        </p:spPr>
+        <p:txBody>
+          <a:bodyPr/>
+          <a:lstStyle/>
+          <a:p/>
+        </p:txBody>
+      </p:sp>
+      <p:sp>
+        <p:nvSpPr>
+          <p:cNvPr id="282" name="Text"/>
+          <p:cNvSpPr txBox="1"/>
+          <p:nvPr/>
+        </p:nvSpPr>
+        <p:spPr>
+          <a:xfrm>
+            <a:off x="9601200" y="3267075"/>
+            <a:ext cx="1381125" cy="323850"/>
+          </a:xfrm>
+          <a:prstGeom prst="rect">
+            <a:avLst/>
+          </a:prstGeom>
+          <a:noFill/>
+          <a:ln>
+            <a:noFill/>
+          </a:ln>
+        </p:spPr>
+        <p:txBody>
+          <a:bodyPr wrap="square" anchor="t">
+            <a:spAutoFit/>
+          </a:bodyPr>
+          <a:lstStyle/>
+          <a:p>
+            <a:pPr algn="l"/>
+            <a:r>
+              <a:rPr lang="en-US" sz="2000">
+                <a:solidFill>
+                  <a:srgbClr val="1F2933"/>
+                </a:solidFill>
+                <a:latin typeface="Arial"/>
+              </a:rPr>
+              <a:t>26.73</a:t>
+            </a:r>
+          </a:p>
+          <a:p>
+            <a:pPr algn="l"/>
+            <a:r>
+              <a:rPr lang="en-US" sz="2000">
+                <a:solidFill>
+                  <a:srgbClr val="1F2933"/>
+                </a:solidFill>
+                <a:latin typeface="Arial"/>
+              </a:rPr>
+              <a:t>n=4</a:t>
+            </a:r>
+          </a:p>
+        </p:txBody>
+      </p:sp>
+      <p:sp>
+        <p:nvSpPr>
+          <p:cNvPr id="285" name="Text"/>
+          <p:cNvSpPr txBox="1"/>
+          <p:nvPr/>
+        </p:nvSpPr>
+        <p:spPr>
+          <a:xfrm>
+            <a:off x="4905375" y="3886200"/>
+            <a:ext cx="2000250" cy="323850"/>
+          </a:xfrm>
+          <a:prstGeom prst="rect">
+            <a:avLst/>
+          </a:prstGeom>
+          <a:noFill/>
+          <a:ln>
+            <a:noFill/>
+          </a:ln>
+        </p:spPr>
+        <p:txBody>
+          <a:bodyPr wrap="square" anchor="t">
+            <a:spAutoFit/>
+          </a:bodyPr>
+          <a:lstStyle/>
+          <a:p>
+            <a:pPr algn="r"/>
+            <a:r>
+              <a:rPr lang="en-US" sz="2000">
+                <a:solidFill>
+                  <a:srgbClr val="1F2933"/>
+                </a:solidFill>
+                <a:latin typeface="Arial"/>
+              </a:rPr>
+              <a:t>BF V2 Fri</a:t>
+            </a:r>
+          </a:p>
+        </p:txBody>
+      </p:sp>
+      <p:sp>
+        <p:nvSpPr>
+          <p:cNvPr id="286" name="Rectangle"/>
+          <p:cNvSpPr/>
+          <p:nvPr/>
+        </p:nvSpPr>
+        <p:spPr>
+          <a:xfrm>
+            <a:off x="7077075" y="3943350"/>
+            <a:ext cx="1806436" cy="171450"/>
+          </a:xfrm>
+          <a:prstGeom prst="roundRect">
+            <a:avLst/>
+          </a:prstGeom>
+          <a:solidFill>
+            <a:srgbClr val="7E57C2"/>
+          </a:solidFill>
+          <a:ln>
+            <a:noFill/>
+          </a:ln>
+        </p:spPr>
+        <p:txBody>
+          <a:bodyPr/>
+          <a:lstStyle/>
+          <a:p/>
+        </p:txBody>
+      </p:sp>
+      <p:sp>
+        <p:nvSpPr>
+          <p:cNvPr id="287" name="Text"/>
+          <p:cNvSpPr txBox="1"/>
+          <p:nvPr/>
+        </p:nvSpPr>
+        <p:spPr>
+          <a:xfrm>
+            <a:off x="8978761" y="3886200"/>
+            <a:ext cx="1381125" cy="323850"/>
+          </a:xfrm>
+          <a:prstGeom prst="rect">
+            <a:avLst/>
+          </a:prstGeom>
+          <a:noFill/>
+          <a:ln>
+            <a:noFill/>
+          </a:ln>
+        </p:spPr>
+        <p:txBody>
+          <a:bodyPr wrap="square" anchor="t">
+            <a:spAutoFit/>
+          </a:bodyPr>
+          <a:lstStyle/>
+          <a:p>
+            <a:pPr algn="l"/>
+            <a:r>
+              <a:rPr lang="en-US" sz="2000">
+                <a:solidFill>
+                  <a:srgbClr val="1F2933"/>
+                </a:solidFill>
+                <a:latin typeface="Arial"/>
+              </a:rPr>
+              <a:t>19.88</a:t>
+            </a:r>
+          </a:p>
+          <a:p>
+            <a:pPr algn="l"/>
+            <a:r>
+              <a:rPr lang="en-US" sz="2000">
+                <a:solidFill>
+                  <a:srgbClr val="1F2933"/>
+                </a:solidFill>
+                <a:latin typeface="Arial"/>
+              </a:rPr>
+              <a:t>n=2</a:t>
+            </a:r>
+          </a:p>
+        </p:txBody>
+      </p:sp>
+      <p:sp>
+        <p:nvSpPr>
+          <p:cNvPr id="290" name="Text"/>
+          <p:cNvSpPr txBox="1"/>
+          <p:nvPr/>
+        </p:nvSpPr>
+        <p:spPr>
+          <a:xfrm>
+            <a:off x="4905375" y="4505325"/>
+            <a:ext cx="2000250" cy="323850"/>
+          </a:xfrm>
+          <a:prstGeom prst="rect">
+            <a:avLst/>
+          </a:prstGeom>
+          <a:noFill/>
+          <a:ln>
+            <a:noFill/>
+          </a:ln>
+        </p:spPr>
+        <p:txBody>
+          <a:bodyPr wrap="square" anchor="t">
+            <a:spAutoFit/>
+          </a:bodyPr>
+          <a:lstStyle/>
+          <a:p>
+            <a:pPr algn="r"/>
+            <a:r>
+              <a:rPr lang="en-US" sz="2000">
+                <a:solidFill>
+                  <a:srgbClr val="1F2933"/>
+                </a:solidFill>
+                <a:latin typeface="Arial"/>
+              </a:rPr>
+              <a:t>BF V2 Mon</a:t>
+            </a:r>
+          </a:p>
+        </p:txBody>
+      </p:sp>
+      <p:sp>
+        <p:nvSpPr>
+          <p:cNvPr id="291" name="Rectangle"/>
+          <p:cNvSpPr/>
+          <p:nvPr/>
+        </p:nvSpPr>
+        <p:spPr>
+          <a:xfrm>
+            <a:off x="7077075" y="4562475"/>
+            <a:ext cx="1598350" cy="171450"/>
+          </a:xfrm>
+          <a:prstGeom prst="roundRect">
+            <a:avLst/>
+          </a:prstGeom>
+          <a:solidFill>
+            <a:srgbClr val="7E57C2"/>
+          </a:solidFill>
+          <a:ln>
+            <a:noFill/>
+          </a:ln>
+        </p:spPr>
+        <p:txBody>
+          <a:bodyPr/>
+          <a:lstStyle/>
+          <a:p/>
+        </p:txBody>
+      </p:sp>
+      <p:sp>
+        <p:nvSpPr>
+          <p:cNvPr id="292" name="Text"/>
+          <p:cNvSpPr txBox="1"/>
+          <p:nvPr/>
+        </p:nvSpPr>
+        <p:spPr>
+          <a:xfrm>
+            <a:off x="8770675" y="4505325"/>
+            <a:ext cx="1381125" cy="323850"/>
+          </a:xfrm>
+          <a:prstGeom prst="rect">
+            <a:avLst/>
+          </a:prstGeom>
+          <a:noFill/>
+          <a:ln>
+            <a:noFill/>
+          </a:ln>
+        </p:spPr>
+        <p:txBody>
+          <a:bodyPr wrap="square" anchor="t">
+            <a:spAutoFit/>
+          </a:bodyPr>
+          <a:lstStyle/>
+          <a:p>
+            <a:pPr algn="l"/>
+            <a:r>
+              <a:rPr lang="en-US" sz="2000">
+                <a:solidFill>
+                  <a:srgbClr val="1F2933"/>
+                </a:solidFill>
+                <a:latin typeface="Arial"/>
+              </a:rPr>
+              <a:t>17.59</a:t>
+            </a:r>
+          </a:p>
+          <a:p>
+            <a:pPr algn="l"/>
+            <a:r>
+              <a:rPr lang="en-US" sz="2000">
+                <a:solidFill>
+                  <a:srgbClr val="1F2933"/>
+                </a:solidFill>
+                <a:latin typeface="Arial"/>
+              </a:rPr>
+              <a:t>n=9</a:t>
+            </a:r>
+          </a:p>
+        </p:txBody>
+      </p:sp>
+      <p:sp>
+        <p:nvSpPr>
+          <p:cNvPr id="295" name="Text"/>
+          <p:cNvSpPr txBox="1"/>
+          <p:nvPr/>
+        </p:nvSpPr>
+        <p:spPr>
+          <a:xfrm>
+            <a:off x="4905375" y="5124450"/>
+            <a:ext cx="2000250" cy="323850"/>
+          </a:xfrm>
+          <a:prstGeom prst="rect">
+            <a:avLst/>
+          </a:prstGeom>
+          <a:noFill/>
+          <a:ln>
+            <a:noFill/>
+          </a:ln>
+        </p:spPr>
+        <p:txBody>
+          <a:bodyPr wrap="square" anchor="t">
+            <a:spAutoFit/>
+          </a:bodyPr>
+          <a:lstStyle/>
+          <a:p>
+            <a:pPr algn="r"/>
+            <a:r>
+              <a:rPr lang="en-US" sz="2000">
+                <a:solidFill>
+                  <a:srgbClr val="1F2933"/>
+                </a:solidFill>
+                <a:latin typeface="Arial"/>
+              </a:rPr>
+              <a:t>BF V1 Sat</a:t>
+            </a:r>
+          </a:p>
+        </p:txBody>
+      </p:sp>
+      <p:sp>
+        <p:nvSpPr>
+          <p:cNvPr id="296" name="Rectangle"/>
+          <p:cNvSpPr/>
+          <p:nvPr/>
+        </p:nvSpPr>
+        <p:spPr>
+          <a:xfrm>
+            <a:off x="7077075" y="5181600"/>
+            <a:ext cx="1595624" cy="171450"/>
+          </a:xfrm>
+          <a:prstGeom prst="roundRect">
+            <a:avLst/>
+          </a:prstGeom>
+          <a:solidFill>
+            <a:srgbClr val="F57C00"/>
+          </a:solidFill>
+          <a:ln>
+            <a:noFill/>
+          </a:ln>
+        </p:spPr>
+        <p:txBody>
+          <a:bodyPr/>
+          <a:lstStyle/>
+          <a:p/>
+        </p:txBody>
+      </p:sp>
+      <p:sp>
+        <p:nvSpPr>
+          <p:cNvPr id="297" name="Text"/>
+          <p:cNvSpPr txBox="1"/>
+          <p:nvPr/>
+        </p:nvSpPr>
+        <p:spPr>
+          <a:xfrm>
+            <a:off x="8767949" y="5124450"/>
+            <a:ext cx="1381125" cy="323850"/>
+          </a:xfrm>
+          <a:prstGeom prst="rect">
+            <a:avLst/>
+          </a:prstGeom>
+          <a:noFill/>
+          <a:ln>
+            <a:noFill/>
+          </a:ln>
+        </p:spPr>
+        <p:txBody>
+          <a:bodyPr wrap="square" anchor="t">
+            <a:spAutoFit/>
+          </a:bodyPr>
+          <a:lstStyle/>
+          <a:p>
+            <a:pPr algn="l"/>
+            <a:r>
+              <a:rPr lang="en-US" sz="2000">
+                <a:solidFill>
+                  <a:srgbClr val="1F2933"/>
+                </a:solidFill>
+                <a:latin typeface="Arial"/>
+              </a:rPr>
+              <a:t>17.56</a:t>
+            </a:r>
+          </a:p>
+          <a:p>
+            <a:pPr algn="l"/>
+            <a:r>
+              <a:rPr lang="en-US" sz="2000">
+                <a:solidFill>
+                  <a:srgbClr val="1F2933"/>
+                </a:solidFill>
+                <a:latin typeface="Arial"/>
+              </a:rPr>
+              <a:t>n=5</a:t>
+            </a:r>
+          </a:p>
+        </p:txBody>
+      </p:sp>
+      <p:sp>
+        <p:nvSpPr>
+          <p:cNvPr id="300" name="Text"/>
+          <p:cNvSpPr txBox="1"/>
+          <p:nvPr/>
+        </p:nvSpPr>
+        <p:spPr>
+          <a:xfrm>
+            <a:off x="4905375" y="5743575"/>
+            <a:ext cx="2000250" cy="323850"/>
+          </a:xfrm>
+          <a:prstGeom prst="rect">
+            <a:avLst/>
+          </a:prstGeom>
+          <a:noFill/>
+          <a:ln>
+            <a:noFill/>
+          </a:ln>
+        </p:spPr>
+        <p:txBody>
+          <a:bodyPr wrap="square" anchor="t">
+            <a:spAutoFit/>
+          </a:bodyPr>
+          <a:lstStyle/>
+          <a:p>
+            <a:pPr algn="r"/>
+            <a:r>
+              <a:rPr lang="en-US" sz="2000">
+                <a:solidFill>
+                  <a:srgbClr val="1F2933"/>
+                </a:solidFill>
+                <a:latin typeface="Arial"/>
+              </a:rPr>
+              <a:t>Holiday V1 Sat</a:t>
+            </a:r>
+          </a:p>
+        </p:txBody>
+      </p:sp>
+      <p:sp>
+        <p:nvSpPr>
+          <p:cNvPr id="301" name="Rectangle"/>
+          <p:cNvSpPr/>
+          <p:nvPr/>
+        </p:nvSpPr>
+        <p:spPr>
+          <a:xfrm>
+            <a:off x="7077075" y="5800725"/>
+            <a:ext cx="1144015" cy="171450"/>
+          </a:xfrm>
+          <a:prstGeom prst="roundRect">
+            <a:avLst/>
+          </a:prstGeom>
+          <a:solidFill>
+            <a:srgbClr val="F57C00"/>
+          </a:solidFill>
+          <a:ln>
+            <a:noFill/>
+          </a:ln>
+        </p:spPr>
+        <p:txBody>
+          <a:bodyPr/>
+          <a:lstStyle/>
+          <a:p/>
+        </p:txBody>
+      </p:sp>
+      <p:sp>
+        <p:nvSpPr>
+          <p:cNvPr id="302" name="Text"/>
+          <p:cNvSpPr txBox="1"/>
+          <p:nvPr/>
+        </p:nvSpPr>
+        <p:spPr>
+          <a:xfrm>
+            <a:off x="8316340" y="5743575"/>
+            <a:ext cx="1381125" cy="323850"/>
+          </a:xfrm>
+          <a:prstGeom prst="rect">
+            <a:avLst/>
+          </a:prstGeom>
+          <a:noFill/>
+          <a:ln>
+            <a:noFill/>
+          </a:ln>
+        </p:spPr>
+        <p:txBody>
+          <a:bodyPr wrap="square" anchor="t">
+            <a:spAutoFit/>
+          </a:bodyPr>
+          <a:lstStyle/>
+          <a:p>
+            <a:pPr algn="l"/>
+            <a:r>
+              <a:rPr lang="en-US" sz="2000">
+                <a:solidFill>
+                  <a:srgbClr val="1F2933"/>
+                </a:solidFill>
+                <a:latin typeface="Arial"/>
+              </a:rPr>
+              <a:t>12.59</a:t>
+            </a:r>
+          </a:p>
+          <a:p>
+            <a:pPr algn="l"/>
+            <a:r>
+              <a:rPr lang="en-US" sz="2000">
+                <a:solidFill>
+                  <a:srgbClr val="1F2933"/>
+                </a:solidFill>
+                <a:latin typeface="Arial"/>
+              </a:rPr>
+              <a:t>n=5</a:t>
+            </a:r>
+          </a:p>
+        </p:txBody>
+      </p:sp>
+      <p:sp>
+        <p:nvSpPr>
+          <p:cNvPr id="305" name="Text"/>
+          <p:cNvSpPr txBox="1"/>
+          <p:nvPr/>
+        </p:nvSpPr>
+        <p:spPr>
+          <a:xfrm>
+            <a:off x="4905375" y="6362700"/>
+            <a:ext cx="2000250" cy="323850"/>
+          </a:xfrm>
+          <a:prstGeom prst="rect">
+            <a:avLst/>
+          </a:prstGeom>
+          <a:noFill/>
+          <a:ln>
+            <a:noFill/>
+          </a:ln>
+        </p:spPr>
+        <p:txBody>
+          <a:bodyPr wrap="square" anchor="t">
+            <a:spAutoFit/>
+          </a:bodyPr>
+          <a:lstStyle/>
+          <a:p>
+            <a:pPr algn="r"/>
+            <a:r>
+              <a:rPr lang="en-US" sz="2000">
+                <a:solidFill>
+                  <a:srgbClr val="1F2933"/>
+                </a:solidFill>
+                <a:latin typeface="Arial"/>
+              </a:rPr>
+              <a:t>Holiday V1 Wed</a:t>
+            </a:r>
+          </a:p>
+        </p:txBody>
+      </p:sp>
+      <p:sp>
+        <p:nvSpPr>
+          <p:cNvPr id="306" name="Rectangle"/>
+          <p:cNvSpPr/>
+          <p:nvPr/>
+        </p:nvSpPr>
+        <p:spPr>
+          <a:xfrm>
+            <a:off x="7077075" y="6419850"/>
+            <a:ext cx="1138563" cy="171450"/>
+          </a:xfrm>
+          <a:prstGeom prst="roundRect">
+            <a:avLst/>
+          </a:prstGeom>
+          <a:solidFill>
+            <a:srgbClr val="F57C00"/>
+          </a:solidFill>
+          <a:ln>
+            <a:noFill/>
+          </a:ln>
+        </p:spPr>
+        <p:txBody>
+          <a:bodyPr/>
+          <a:lstStyle/>
+          <a:p/>
+        </p:txBody>
+      </p:sp>
+      <p:sp>
+        <p:nvSpPr>
+          <p:cNvPr id="307" name="Text"/>
+          <p:cNvSpPr txBox="1"/>
+          <p:nvPr/>
+        </p:nvSpPr>
+        <p:spPr>
+          <a:xfrm>
+            <a:off x="8310888" y="6362700"/>
+            <a:ext cx="1381125" cy="323850"/>
+          </a:xfrm>
+          <a:prstGeom prst="rect">
+            <a:avLst/>
+          </a:prstGeom>
+          <a:noFill/>
+          <a:ln>
+            <a:noFill/>
+          </a:ln>
+        </p:spPr>
+        <p:txBody>
+          <a:bodyPr wrap="square" anchor="t">
+            <a:spAutoFit/>
+          </a:bodyPr>
+          <a:lstStyle/>
+          <a:p>
+            <a:pPr algn="l"/>
+            <a:r>
+              <a:rPr lang="en-US" sz="2000">
+                <a:solidFill>
+                  <a:srgbClr val="1F2933"/>
+                </a:solidFill>
+                <a:latin typeface="Arial"/>
+              </a:rPr>
+              <a:t>12.53</a:t>
+            </a:r>
+          </a:p>
+          <a:p>
+            <a:pPr algn="l"/>
+            <a:r>
+              <a:rPr lang="en-US" sz="2000">
+                <a:solidFill>
+                  <a:srgbClr val="1F2933"/>
+                </a:solidFill>
+                <a:latin typeface="Arial"/>
+              </a:rPr>
+              <a:t>n=2</a:t>
+            </a:r>
+          </a:p>
+        </p:txBody>
+      </p:sp>
+      <p:sp>
+        <p:nvSpPr>
+          <p:cNvPr id="360" name="Rectangle"/>
+          <p:cNvSpPr/>
+          <p:nvPr/>
+        </p:nvSpPr>
+        <p:spPr>
+          <a:xfrm>
+            <a:off x="904875" y="3000375"/>
+            <a:ext cx="3429000" cy="1571625"/>
           </a:xfrm>
           <a:prstGeom prst="roundRect">
             <a:avLst/>
@@ -4292,39 +5119,37 @@
         <p:txBody>
           <a:bodyPr/>
           <a:lstStyle/>
-          <a:p>
-            <a:endParaRPr/>
-          </a:p>
-        </p:txBody>
-      </p:sp>
-      <p:sp>
-        <p:nvSpPr>
-          <p:cNvPr id="281" name="Text"/>
+          <a:p/>
+        </p:txBody>
+      </p:sp>
+      <p:sp>
+        <p:nvSpPr>
+          <p:cNvPr id="361" name="Text"/>
           <p:cNvSpPr txBox="1"/>
           <p:nvPr/>
         </p:nvSpPr>
         <p:spPr>
           <a:xfrm>
             <a:off x="1190625" y="3238500"/>
-            <a:ext cx="3913638" cy="707886"/>
-          </a:xfrm>
-          <a:prstGeom prst="rect">
-            <a:avLst/>
-          </a:prstGeom>
-          <a:noFill/>
-          <a:ln>
-            <a:noFill/>
-          </a:ln>
-        </p:spPr>
-        <p:txBody>
-          <a:bodyPr wrap="square" anchor="t">
-            <a:spAutoFit/>
-          </a:bodyPr>
-          <a:lstStyle/>
-          <a:p>
-            <a:pPr algn="l"/>
-            <a:r>
-              <a:rPr lang="en-US" sz="2000" b="1" dirty="0">
+            <a:ext cx="2857500" cy="495300"/>
+          </a:xfrm>
+          <a:prstGeom prst="rect">
+            <a:avLst/>
+          </a:prstGeom>
+          <a:noFill/>
+          <a:ln>
+            <a:noFill/>
+          </a:ln>
+        </p:spPr>
+        <p:txBody>
+          <a:bodyPr wrap="square" anchor="t">
+            <a:spAutoFit/>
+          </a:bodyPr>
+          <a:lstStyle/>
+          <a:p>
+            <a:pPr algn="c"/>
+            <a:r>
+              <a:rPr lang="en-US" sz="2000" b="1">
                 <a:solidFill>
                   <a:srgbClr val="1F2933"/>
                 </a:solidFill>
@@ -4334,9 +5159,9 @@
             </a:r>
           </a:p>
           <a:p>
-            <a:pPr algn="l"/>
-            <a:r>
-              <a:rPr lang="en-US" sz="2000" b="1" dirty="0">
+            <a:pPr algn="c"/>
+            <a:r>
+              <a:rPr lang="en-US" sz="2000" b="1">
                 <a:solidFill>
                   <a:srgbClr val="1F2933"/>
                 </a:solidFill>
@@ -4349,32 +5174,32 @@
       </p:sp>
       <p:sp>
         <p:nvSpPr>
-          <p:cNvPr id="282" name="Text"/>
-          <p:cNvSpPr txBox="1"/>
-          <p:nvPr/>
-        </p:nvSpPr>
-        <p:spPr>
-          <a:xfrm>
-            <a:off x="1190625" y="3829050"/>
-            <a:ext cx="2857500" cy="646331"/>
-          </a:xfrm>
-          <a:prstGeom prst="rect">
-            <a:avLst/>
-          </a:prstGeom>
-          <a:noFill/>
-          <a:ln>
-            <a:noFill/>
-          </a:ln>
-        </p:spPr>
-        <p:txBody>
-          <a:bodyPr wrap="square" anchor="t">
-            <a:spAutoFit/>
-          </a:bodyPr>
-          <a:lstStyle/>
-          <a:p>
-            <a:pPr algn="l"/>
-            <a:r>
-              <a:rPr lang="en-US" b="1" dirty="0">
+          <p:cNvPr id="362" name="Text"/>
+          <p:cNvSpPr txBox="1"/>
+          <p:nvPr/>
+        </p:nvSpPr>
+        <p:spPr>
+          <a:xfrm>
+            <a:off x="1190625" y="3857625"/>
+            <a:ext cx="2857500" cy="552450"/>
+          </a:xfrm>
+          <a:prstGeom prst="rect">
+            <a:avLst/>
+          </a:prstGeom>
+          <a:noFill/>
+          <a:ln>
+            <a:noFill/>
+          </a:ln>
+        </p:spPr>
+        <p:txBody>
+          <a:bodyPr wrap="square" anchor="t">
+            <a:spAutoFit/>
+          </a:bodyPr>
+          <a:lstStyle/>
+          <a:p>
+            <a:pPr algn="c"/>
+            <a:r>
+              <a:rPr lang="en-US" sz="2000" b="1">
                 <a:solidFill>
                   <a:srgbClr val="F57C00"/>
                 </a:solidFill>
@@ -4384,28 +5209,28 @@
             </a:r>
           </a:p>
           <a:p>
-            <a:pPr algn="l"/>
-            <a:r>
-              <a:rPr lang="en-US" b="1" dirty="0">
+            <a:pPr algn="c"/>
+            <a:r>
+              <a:rPr lang="en-US" sz="2000" b="1">
                 <a:solidFill>
                   <a:srgbClr val="F57C00"/>
                 </a:solidFill>
                 <a:latin typeface="Arial"/>
               </a:rPr>
-              <a:t>n = 2 sessions</a:t>
-            </a:r>
-          </a:p>
-        </p:txBody>
-      </p:sp>
-      <p:sp>
-        <p:nvSpPr>
-          <p:cNvPr id="283" name="Text"/>
-          <p:cNvSpPr txBox="1"/>
-          <p:nvPr/>
-        </p:nvSpPr>
-        <p:spPr>
-          <a:xfrm>
-            <a:off x="904875" y="4619625"/>
+              <a:t>n=2</a:t>
+            </a:r>
+          </a:p>
+        </p:txBody>
+      </p:sp>
+      <p:sp>
+        <p:nvSpPr>
+          <p:cNvPr id="363" name="Text"/>
+          <p:cNvSpPr txBox="1"/>
+          <p:nvPr/>
+        </p:nvSpPr>
+        <p:spPr>
+          <a:xfrm>
+            <a:off x="904875" y="4857750"/>
             <a:ext cx="3476625" cy="619125"/>
           </a:xfrm>
           <a:prstGeom prst="rect">
@@ -4430,7 +5255,7 @@
                 </a:solidFill>
                 <a:latin typeface="Arial"/>
               </a:rPr>
-              <a:t>Answer to review question: it did not take longer than 1 hour.</a:t>
+              <a:t>Answer to stakeholder question: it did not take longer than 1 hour.</a:t>
             </a:r>
           </a:p>
         </p:txBody>
@@ -4451,7 +5276,6 @@
         <a:solidFill>
           <a:srgbClr val="F7F9FC"/>
         </a:solidFill>
-        <a:effectLst/>
       </p:bgPr>
     </p:bg>
     <p:spTree>
@@ -4629,9 +5453,7 @@
         <p:txBody>
           <a:bodyPr/>
           <a:lstStyle/>
-          <a:p>
-            <a:endParaRPr/>
-          </a:p>
+          <a:p/>
         </p:txBody>
       </p:sp>
       <p:sp>
@@ -4696,9 +5518,7 @@
         <p:txBody>
           <a:bodyPr/>
           <a:lstStyle/>
-          <a:p>
-            <a:endParaRPr/>
-          </a:p>
+          <a:p/>
         </p:txBody>
       </p:sp>
       <p:sp>
@@ -4763,9 +5583,7 @@
         <p:txBody>
           <a:bodyPr/>
           <a:lstStyle/>
-          <a:p>
-            <a:endParaRPr/>
-          </a:p>
+          <a:p/>
         </p:txBody>
       </p:sp>
       <p:sp>
@@ -4830,9 +5648,7 @@
         <p:txBody>
           <a:bodyPr/>
           <a:lstStyle/>
-          <a:p>
-            <a:endParaRPr/>
-          </a:p>
+          <a:p/>
         </p:txBody>
       </p:sp>
       <p:sp>
@@ -4899,9 +5715,7 @@
         <p:txBody>
           <a:bodyPr/>
           <a:lstStyle/>
-          <a:p>
-            <a:endParaRPr/>
-          </a:p>
+          <a:p/>
         </p:txBody>
       </p:sp>
       <p:sp>
@@ -4966,9 +5780,7 @@
         <p:txBody>
           <a:bodyPr/>
           <a:lstStyle/>
-          <a:p>
-            <a:endParaRPr/>
-          </a:p>
+          <a:p/>
         </p:txBody>
       </p:sp>
       <p:sp>
@@ -5033,9 +5845,7 @@
         <p:txBody>
           <a:bodyPr/>
           <a:lstStyle/>
-          <a:p>
-            <a:endParaRPr/>
-          </a:p>
+          <a:p/>
         </p:txBody>
       </p:sp>
       <p:sp>
@@ -5100,9 +5910,7 @@
         <p:txBody>
           <a:bodyPr/>
           <a:lstStyle/>
-          <a:p>
-            <a:endParaRPr/>
-          </a:p>
+          <a:p/>
         </p:txBody>
       </p:sp>
       <p:sp>
@@ -5168,7 +5976,7 @@
           </a:bodyPr>
           <a:lstStyle/>
           <a:p>
-            <a:pPr algn="l"/>
+            <a:pPr algn="c"/>
             <a:r>
               <a:rPr lang="en-US" sz="2000" b="1">
                 <a:solidFill>
@@ -5197,7 +6005,6 @@
         <a:solidFill>
           <a:srgbClr val="F7F9FC"/>
         </a:solidFill>
-        <a:effectLst/>
       </p:bgPr>
     </p:bg>
     <p:spTree>
@@ -5373,9 +6180,7 @@
         <p:txBody>
           <a:bodyPr/>
           <a:lstStyle/>
-          <a:p>
-            <a:endParaRPr/>
-          </a:p>
+          <a:p/>
         </p:txBody>
       </p:sp>
       <p:sp>
@@ -5440,9 +6245,7 @@
         <p:txBody>
           <a:bodyPr/>
           <a:lstStyle/>
-          <a:p>
-            <a:endParaRPr/>
-          </a:p>
+          <a:p/>
         </p:txBody>
       </p:sp>
       <p:sp>
@@ -5507,9 +6310,7 @@
         <p:txBody>
           <a:bodyPr/>
           <a:lstStyle/>
-          <a:p>
-            <a:endParaRPr/>
-          </a:p>
+          <a:p/>
         </p:txBody>
       </p:sp>
       <p:sp>
@@ -5574,9 +6375,7 @@
         <p:txBody>
           <a:bodyPr/>
           <a:lstStyle/>
-          <a:p>
-            <a:endParaRPr/>
-          </a:p>
+          <a:p/>
         </p:txBody>
       </p:sp>
       <p:sp>
@@ -5641,9 +6440,7 @@
         <p:txBody>
           <a:bodyPr/>
           <a:lstStyle/>
-          <a:p>
-            <a:endParaRPr/>
-          </a:p>
+          <a:p/>
         </p:txBody>
       </p:sp>
       <p:sp>
@@ -5700,7 +6497,6 @@
         <a:solidFill>
           <a:srgbClr val="F7F9FC"/>
         </a:solidFill>
-        <a:effectLst/>
       </p:bgPr>
     </p:bg>
     <p:spTree>
@@ -5861,7 +6657,7 @@
         <p:spPr>
           <a:xfrm>
             <a:off x="904875" y="2857500"/>
-            <a:ext cx="2857500" cy="1386949"/>
+            <a:ext cx="2857500" cy="1619250"/>
           </a:xfrm>
           <a:prstGeom prst="roundRect">
             <a:avLst/>
@@ -5878,9 +6674,7 @@
         <p:txBody>
           <a:bodyPr/>
           <a:lstStyle/>
-          <a:p>
-            <a:endParaRPr/>
-          </a:p>
+          <a:p/>
         </p:txBody>
       </p:sp>
       <p:sp>
@@ -5908,7 +6702,7 @@
           </a:bodyPr>
           <a:lstStyle/>
           <a:p>
-            <a:pPr algn="l"/>
+            <a:pPr algn="c"/>
             <a:r>
               <a:rPr lang="en-US" sz="2000" b="1">
                 <a:solidFill>
@@ -5946,7 +6740,7 @@
           </a:bodyPr>
           <a:lstStyle/>
           <a:p>
-            <a:pPr algn="l"/>
+            <a:pPr algn="c"/>
             <a:r>
               <a:rPr lang="en-US" sz="2000" b="1">
                 <a:solidFill>
@@ -5958,7 +6752,7 @@
             </a:r>
           </a:p>
           <a:p>
-            <a:pPr algn="l"/>
+            <a:pPr algn="c"/>
             <a:r>
               <a:rPr lang="en-US" sz="2000" b="1">
                 <a:solidFill>
@@ -5980,7 +6774,7 @@
         <p:spPr>
           <a:xfrm>
             <a:off x="4572000" y="2857500"/>
-            <a:ext cx="2857500" cy="1386949"/>
+            <a:ext cx="2857500" cy="1619250"/>
           </a:xfrm>
           <a:prstGeom prst="roundRect">
             <a:avLst/>
@@ -5997,9 +6791,7 @@
         <p:txBody>
           <a:bodyPr/>
           <a:lstStyle/>
-          <a:p>
-            <a:endParaRPr/>
-          </a:p>
+          <a:p/>
         </p:txBody>
       </p:sp>
       <p:sp>
@@ -6027,7 +6819,7 @@
           </a:bodyPr>
           <a:lstStyle/>
           <a:p>
-            <a:pPr algn="l"/>
+            <a:pPr algn="c"/>
             <a:r>
               <a:rPr lang="en-US" sz="2000" b="1">
                 <a:solidFill>
@@ -6065,7 +6857,7 @@
           </a:bodyPr>
           <a:lstStyle/>
           <a:p>
-            <a:pPr algn="l"/>
+            <a:pPr algn="c"/>
             <a:r>
               <a:rPr lang="en-US" sz="2000" b="1">
                 <a:solidFill>
@@ -6077,7 +6869,7 @@
             </a:r>
           </a:p>
           <a:p>
-            <a:pPr algn="l"/>
+            <a:pPr algn="c"/>
             <a:r>
               <a:rPr lang="en-US" sz="2000" b="1">
                 <a:solidFill>
@@ -6099,7 +6891,7 @@
         <p:spPr>
           <a:xfrm>
             <a:off x="8239125" y="2857500"/>
-            <a:ext cx="2857500" cy="1386949"/>
+            <a:ext cx="2857500" cy="1619250"/>
           </a:xfrm>
           <a:prstGeom prst="roundRect">
             <a:avLst/>
@@ -6116,9 +6908,7 @@
         <p:txBody>
           <a:bodyPr/>
           <a:lstStyle/>
-          <a:p>
-            <a:endParaRPr/>
-          </a:p>
+          <a:p/>
         </p:txBody>
       </p:sp>
       <p:sp>
@@ -6146,7 +6936,7 @@
           </a:bodyPr>
           <a:lstStyle/>
           <a:p>
-            <a:pPr algn="l"/>
+            <a:pPr algn="c"/>
             <a:r>
               <a:rPr lang="en-US" sz="2000" b="1">
                 <a:solidFill>
@@ -6184,7 +6974,7 @@
           </a:bodyPr>
           <a:lstStyle/>
           <a:p>
-            <a:pPr algn="l"/>
+            <a:pPr algn="c"/>
             <a:r>
               <a:rPr lang="en-US" sz="2000" b="1">
                 <a:solidFill>
@@ -6196,7 +6986,7 @@
             </a:r>
           </a:p>
           <a:p>
-            <a:pPr algn="l"/>
+            <a:pPr algn="c"/>
             <a:r>
               <a:rPr lang="en-US" sz="2000" b="1">
                 <a:solidFill>
@@ -6233,9 +7023,7 @@
         <p:txBody>
           <a:bodyPr/>
           <a:lstStyle/>
-          <a:p>
-            <a:endParaRPr/>
-          </a:p>
+          <a:p/>
         </p:txBody>
       </p:sp>
       <p:sp>
@@ -6300,9 +7088,7 @@
         <p:txBody>
           <a:bodyPr/>
           <a:lstStyle/>
-          <a:p>
-            <a:endParaRPr/>
-          </a:p>
+          <a:p/>
         </p:txBody>
       </p:sp>
       <p:sp>
@@ -6367,9 +7153,7 @@
         <p:txBody>
           <a:bodyPr/>
           <a:lstStyle/>
-          <a:p>
-            <a:endParaRPr/>
-          </a:p>
+          <a:p/>
         </p:txBody>
       </p:sp>
       <p:sp>
@@ -6419,631 +7203,78 @@
 </file>
 
 <file path=ppt/theme/theme1.xml><?xml version="1.0" encoding="utf-8"?>
-<a:theme xmlns:a="http://schemas.openxmlformats.org/drawingml/2006/main" name="Office Theme">
+<a:theme xmlns:a="http://schemas.openxmlformats.org/drawingml/2006/main" name="Product Analyst Theme">
   <a:themeElements>
-    <a:clrScheme name="Office">
+    <a:clrScheme name="Product Analyst">
       <a:dk1>
-        <a:sysClr val="windowText" lastClr="000000"/>
+        <a:srgbClr val="1F2933"/>
       </a:dk1>
       <a:lt1>
-        <a:sysClr val="window" lastClr="FFFFFF"/>
+        <a:srgbClr val="FFFFFF"/>
       </a:lt1>
       <a:dk2>
-        <a:srgbClr val="0E2841"/>
+        <a:srgbClr val="5F6B7A"/>
       </a:dk2>
       <a:lt2>
-        <a:srgbClr val="E8E8E8"/>
+        <a:srgbClr val="F7F9FC"/>
       </a:lt2>
       <a:accent1>
-        <a:srgbClr val="156082"/>
+        <a:srgbClr val="1F77B4"/>
       </a:accent1>
       <a:accent2>
-        <a:srgbClr val="E97132"/>
+        <a:srgbClr val="188038"/>
       </a:accent2>
       <a:accent3>
-        <a:srgbClr val="196B24"/>
+        <a:srgbClr val="F57C00"/>
       </a:accent3>
       <a:accent4>
-        <a:srgbClr val="0F9ED5"/>
+        <a:srgbClr val="7E57C2"/>
       </a:accent4>
       <a:accent5>
-        <a:srgbClr val="A02B93"/>
+        <a:srgbClr val="C25746"/>
       </a:accent5>
       <a:accent6>
-        <a:srgbClr val="4EA72E"/>
+        <a:srgbClr val="9CA3AF"/>
       </a:accent6>
       <a:hlink>
-        <a:srgbClr val="467886"/>
+        <a:srgbClr val="1F77B4"/>
       </a:hlink>
       <a:folHlink>
-        <a:srgbClr val="96607D"/>
+        <a:srgbClr val="7E57C2"/>
       </a:folHlink>
     </a:clrScheme>
-    <a:fontScheme name="Office">
+    <a:fontScheme name="Arial">
       <a:majorFont>
-        <a:latin typeface="Aptos Display" panose="02110004020202020204"/>
-        <a:ea typeface=""/>
-        <a:cs typeface=""/>
-        <a:font script="Jpan" typeface="游ゴシック Light"/>
-        <a:font script="Hang" typeface="맑은 고딕"/>
-        <a:font script="Hans" typeface="等线 Light"/>
-        <a:font script="Hant" typeface="新細明體"/>
-        <a:font script="Arab" typeface="Times New Roman"/>
-        <a:font script="Hebr" typeface="Times New Roman"/>
-        <a:font script="Thai" typeface="Angsana New"/>
-        <a:font script="Ethi" typeface="Nyala"/>
-        <a:font script="Beng" typeface="Vrinda"/>
-        <a:font script="Gujr" typeface="Shruti"/>
-        <a:font script="Khmr" typeface="MoolBoran"/>
-        <a:font script="Knda" typeface="Tunga"/>
-        <a:font script="Guru" typeface="Raavi"/>
-        <a:font script="Cans" typeface="Euphemia"/>
-        <a:font script="Cher" typeface="Plantagenet Cherokee"/>
-        <a:font script="Yiii" typeface="Microsoft Yi Baiti"/>
-        <a:font script="Tibt" typeface="Microsoft Himalaya"/>
-        <a:font script="Thaa" typeface="MV Boli"/>
-        <a:font script="Deva" typeface="Mangal"/>
-        <a:font script="Telu" typeface="Gautami"/>
-        <a:font script="Taml" typeface="Latha"/>
-        <a:font script="Syrc" typeface="Estrangelo Edessa"/>
-        <a:font script="Orya" typeface="Kalinga"/>
-        <a:font script="Mlym" typeface="Kartika"/>
-        <a:font script="Laoo" typeface="DokChampa"/>
-        <a:font script="Sinh" typeface="Iskoola Pota"/>
-        <a:font script="Mong" typeface="Mongolian Baiti"/>
-        <a:font script="Viet" typeface="Times New Roman"/>
-        <a:font script="Uigh" typeface="Microsoft Uighur"/>
-        <a:font script="Geor" typeface="Sylfaen"/>
-        <a:font script="Armn" typeface="Arial"/>
-        <a:font script="Bugi" typeface="Leelawadee UI"/>
-        <a:font script="Bopo" typeface="Microsoft JhengHei"/>
-        <a:font script="Java" typeface="Javanese Text"/>
-        <a:font script="Lisu" typeface="Segoe UI"/>
-        <a:font script="Mymr" typeface="Myanmar Text"/>
-        <a:font script="Nkoo" typeface="Ebrima"/>
-        <a:font script="Olck" typeface="Nirmala UI"/>
-        <a:font script="Osma" typeface="Ebrima"/>
-        <a:font script="Phag" typeface="Phagspa"/>
-        <a:font script="Syrn" typeface="Estrangelo Edessa"/>
-        <a:font script="Syrj" typeface="Estrangelo Edessa"/>
-        <a:font script="Syre" typeface="Estrangelo Edessa"/>
-        <a:font script="Sora" typeface="Nirmala UI"/>
-        <a:font script="Tale" typeface="Microsoft Tai Le"/>
-        <a:font script="Talu" typeface="Microsoft New Tai Lue"/>
-        <a:font script="Tfng" typeface="Ebrima"/>
+        <a:latin typeface="Arial"/>
       </a:majorFont>
       <a:minorFont>
-        <a:latin typeface="Aptos" panose="02110004020202020204"/>
-        <a:ea typeface=""/>
-        <a:cs typeface=""/>
-        <a:font script="Jpan" typeface="游ゴシック"/>
-        <a:font script="Hang" typeface="맑은 고딕"/>
-        <a:font script="Hans" typeface="等线"/>
-        <a:font script="Hant" typeface="新細明體"/>
-        <a:font script="Arab" typeface="Arial"/>
-        <a:font script="Hebr" typeface="Arial"/>
-        <a:font script="Thai" typeface="Cordia New"/>
-        <a:font script="Ethi" typeface="Nyala"/>
-        <a:font script="Beng" typeface="Vrinda"/>
-        <a:font script="Gujr" typeface="Shruti"/>
-        <a:font script="Khmr" typeface="DaunPenh"/>
-        <a:font script="Knda" typeface="Tunga"/>
-        <a:font script="Guru" typeface="Raavi"/>
-        <a:font script="Cans" typeface="Euphemia"/>
-        <a:font script="Cher" typeface="Plantagenet Cherokee"/>
-        <a:font script="Yiii" typeface="Microsoft Yi Baiti"/>
-        <a:font script="Tibt" typeface="Microsoft Himalaya"/>
-        <a:font script="Thaa" typeface="MV Boli"/>
-        <a:font script="Deva" typeface="Mangal"/>
-        <a:font script="Telu" typeface="Gautami"/>
-        <a:font script="Taml" typeface="Latha"/>
-        <a:font script="Syrc" typeface="Estrangelo Edessa"/>
-        <a:font script="Orya" typeface="Kalinga"/>
-        <a:font script="Mlym" typeface="Kartika"/>
-        <a:font script="Laoo" typeface="DokChampa"/>
-        <a:font script="Sinh" typeface="Iskoola Pota"/>
-        <a:font script="Mong" typeface="Mongolian Baiti"/>
-        <a:font script="Viet" typeface="Arial"/>
-        <a:font script="Uigh" typeface="Microsoft Uighur"/>
-        <a:font script="Geor" typeface="Sylfaen"/>
-        <a:font script="Armn" typeface="Arial"/>
-        <a:font script="Bugi" typeface="Leelawadee UI"/>
-        <a:font script="Bopo" typeface="Microsoft JhengHei"/>
-        <a:font script="Java" typeface="Javanese Text"/>
-        <a:font script="Lisu" typeface="Segoe UI"/>
-        <a:font script="Mymr" typeface="Myanmar Text"/>
-        <a:font script="Nkoo" typeface="Ebrima"/>
-        <a:font script="Olck" typeface="Nirmala UI"/>
-        <a:font script="Osma" typeface="Ebrima"/>
-        <a:font script="Phag" typeface="Phagspa"/>
-        <a:font script="Syrn" typeface="Estrangelo Edessa"/>
-        <a:font script="Syrj" typeface="Estrangelo Edessa"/>
-        <a:font script="Syre" typeface="Estrangelo Edessa"/>
-        <a:font script="Sora" typeface="Nirmala UI"/>
-        <a:font script="Tale" typeface="Microsoft Tai Le"/>
-        <a:font script="Talu" typeface="Microsoft New Tai Lue"/>
-        <a:font script="Tfng" typeface="Ebrima"/>
+        <a:latin typeface="Arial"/>
       </a:minorFont>
     </a:fontScheme>
-    <a:fmtScheme name="Office">
+    <a:fmtScheme name="Default">
       <a:fillStyleLst>
         <a:solidFill>
           <a:schemeClr val="phClr"/>
         </a:solidFill>
-        <a:gradFill rotWithShape="1">
-          <a:gsLst>
-            <a:gs pos="0">
-              <a:schemeClr val="phClr">
-                <a:lumMod val="110000"/>
-                <a:satMod val="105000"/>
-                <a:tint val="67000"/>
-              </a:schemeClr>
-            </a:gs>
-            <a:gs pos="50000">
-              <a:schemeClr val="phClr">
-                <a:lumMod val="105000"/>
-                <a:satMod val="103000"/>
-                <a:tint val="73000"/>
-              </a:schemeClr>
-            </a:gs>
-            <a:gs pos="100000">
-              <a:schemeClr val="phClr">
-                <a:lumMod val="105000"/>
-                <a:satMod val="109000"/>
-                <a:tint val="81000"/>
-              </a:schemeClr>
-            </a:gs>
-          </a:gsLst>
-          <a:lin ang="5400000" scaled="0"/>
-        </a:gradFill>
-        <a:gradFill rotWithShape="1">
-          <a:gsLst>
-            <a:gs pos="0">
-              <a:schemeClr val="phClr">
-                <a:satMod val="103000"/>
-                <a:lumMod val="102000"/>
-                <a:tint val="94000"/>
-              </a:schemeClr>
-            </a:gs>
-            <a:gs pos="50000">
-              <a:schemeClr val="phClr">
-                <a:satMod val="110000"/>
-                <a:lumMod val="100000"/>
-                <a:shade val="100000"/>
-              </a:schemeClr>
-            </a:gs>
-            <a:gs pos="100000">
-              <a:schemeClr val="phClr">
-                <a:lumMod val="99000"/>
-                <a:satMod val="120000"/>
-                <a:shade val="78000"/>
-              </a:schemeClr>
-            </a:gs>
-          </a:gsLst>
-          <a:lin ang="5400000" scaled="0"/>
-        </a:gradFill>
       </a:fillStyleLst>
       <a:lnStyleLst>
-        <a:ln w="12700" cap="flat" cmpd="sng" algn="ctr">
+        <a:ln w="9525">
           <a:solidFill>
             <a:schemeClr val="phClr"/>
           </a:solidFill>
-          <a:prstDash val="solid"/>
-          <a:miter lim="800000"/>
-        </a:ln>
-        <a:ln w="19050" cap="flat" cmpd="sng" algn="ctr">
-          <a:solidFill>
-            <a:schemeClr val="phClr"/>
-          </a:solidFill>
-          <a:prstDash val="solid"/>
-          <a:miter lim="800000"/>
-        </a:ln>
-        <a:ln w="25400" cap="flat" cmpd="sng" algn="ctr">
-          <a:solidFill>
-            <a:schemeClr val="phClr"/>
-          </a:solidFill>
-          <a:prstDash val="solid"/>
-          <a:miter lim="800000"/>
         </a:ln>
       </a:lnStyleLst>
       <a:effectStyleLst>
         <a:effectStyle>
           <a:effectLst/>
         </a:effectStyle>
-        <a:effectStyle>
-          <a:effectLst/>
-        </a:effectStyle>
-        <a:effectStyle>
-          <a:effectLst>
-            <a:outerShdw blurRad="57150" dist="19050" dir="5400000" algn="ctr" rotWithShape="0">
-              <a:srgbClr val="000000">
-                <a:alpha val="63000"/>
-              </a:srgbClr>
-            </a:outerShdw>
-          </a:effectLst>
-        </a:effectStyle>
       </a:effectStyleLst>
       <a:bgFillStyleLst>
         <a:solidFill>
           <a:schemeClr val="phClr"/>
         </a:solidFill>
-        <a:solidFill>
-          <a:schemeClr val="phClr">
-            <a:tint val="95000"/>
-            <a:satMod val="170000"/>
-          </a:schemeClr>
-        </a:solidFill>
-        <a:gradFill rotWithShape="1">
-          <a:gsLst>
-            <a:gs pos="0">
-              <a:schemeClr val="phClr">
-                <a:tint val="93000"/>
-                <a:satMod val="150000"/>
-                <a:shade val="98000"/>
-                <a:lumMod val="102000"/>
-              </a:schemeClr>
-            </a:gs>
-            <a:gs pos="50000">
-              <a:schemeClr val="phClr">
-                <a:tint val="98000"/>
-                <a:satMod val="130000"/>
-                <a:shade val="90000"/>
-                <a:lumMod val="103000"/>
-              </a:schemeClr>
-            </a:gs>
-            <a:gs pos="100000">
-              <a:schemeClr val="phClr">
-                <a:shade val="63000"/>
-                <a:satMod val="120000"/>
-              </a:schemeClr>
-            </a:gs>
-          </a:gsLst>
-          <a:lin ang="5400000" scaled="0"/>
-        </a:gradFill>
       </a:bgFillStyleLst>
     </a:fmtScheme>
   </a:themeElements>
-  <a:objectDefaults>
-    <a:lnDef>
-      <a:spPr/>
-      <a:bodyPr/>
-      <a:lstStyle/>
-      <a:style>
-        <a:lnRef idx="2">
-          <a:schemeClr val="accent1"/>
-        </a:lnRef>
-        <a:fillRef idx="0">
-          <a:schemeClr val="accent1"/>
-        </a:fillRef>
-        <a:effectRef idx="1">
-          <a:schemeClr val="accent1"/>
-        </a:effectRef>
-        <a:fontRef idx="minor">
-          <a:schemeClr val="tx1"/>
-        </a:fontRef>
-      </a:style>
-    </a:lnDef>
-  </a:objectDefaults>
-  <a:extraClrSchemeLst/>
-  <a:extLst>
-    <a:ext uri="{05A4C25C-085E-4340-85A3-A5531E510DB2}">
-      <thm15:themeFamily xmlns:thm15="http://schemas.microsoft.com/office/thememl/2012/main" name="Office Theme" id="{2E142A2C-CD16-42D6-873A-C26D2A0506FA}" vid="{1BDDFF52-6CD6-40A5-AB3C-68EB2F1E4D0A}"/>
-    </a:ext>
-  </a:extLst>
-</a:theme>
-</file>
-
-<file path=ppt/theme/theme2.xml><?xml version="1.0" encoding="utf-8"?>
-<a:theme xmlns:a="http://schemas.openxmlformats.org/drawingml/2006/main" name="Office Theme">
-  <a:themeElements>
-    <a:clrScheme name="Office">
-      <a:dk1>
-        <a:sysClr val="windowText" lastClr="000000"/>
-      </a:dk1>
-      <a:lt1>
-        <a:sysClr val="window" lastClr="FFFFFF"/>
-      </a:lt1>
-      <a:dk2>
-        <a:srgbClr val="0E2841"/>
-      </a:dk2>
-      <a:lt2>
-        <a:srgbClr val="E8E8E8"/>
-      </a:lt2>
-      <a:accent1>
-        <a:srgbClr val="156082"/>
-      </a:accent1>
-      <a:accent2>
-        <a:srgbClr val="E97132"/>
-      </a:accent2>
-      <a:accent3>
-        <a:srgbClr val="196B24"/>
-      </a:accent3>
-      <a:accent4>
-        <a:srgbClr val="0F9ED5"/>
-      </a:accent4>
-      <a:accent5>
-        <a:srgbClr val="A02B93"/>
-      </a:accent5>
-      <a:accent6>
-        <a:srgbClr val="4EA72E"/>
-      </a:accent6>
-      <a:hlink>
-        <a:srgbClr val="467886"/>
-      </a:hlink>
-      <a:folHlink>
-        <a:srgbClr val="96607D"/>
-      </a:folHlink>
-    </a:clrScheme>
-    <a:fontScheme name="Office">
-      <a:majorFont>
-        <a:latin typeface="Aptos Display" panose="02110004020202020204"/>
-        <a:ea typeface=""/>
-        <a:cs typeface=""/>
-        <a:font script="Jpan" typeface="游ゴシック Light"/>
-        <a:font script="Hang" typeface="맑은 고딕"/>
-        <a:font script="Hans" typeface="等线 Light"/>
-        <a:font script="Hant" typeface="新細明體"/>
-        <a:font script="Arab" typeface="Times New Roman"/>
-        <a:font script="Hebr" typeface="Times New Roman"/>
-        <a:font script="Thai" typeface="Angsana New"/>
-        <a:font script="Ethi" typeface="Nyala"/>
-        <a:font script="Beng" typeface="Vrinda"/>
-        <a:font script="Gujr" typeface="Shruti"/>
-        <a:font script="Khmr" typeface="MoolBoran"/>
-        <a:font script="Knda" typeface="Tunga"/>
-        <a:font script="Guru" typeface="Raavi"/>
-        <a:font script="Cans" typeface="Euphemia"/>
-        <a:font script="Cher" typeface="Plantagenet Cherokee"/>
-        <a:font script="Yiii" typeface="Microsoft Yi Baiti"/>
-        <a:font script="Tibt" typeface="Microsoft Himalaya"/>
-        <a:font script="Thaa" typeface="MV Boli"/>
-        <a:font script="Deva" typeface="Mangal"/>
-        <a:font script="Telu" typeface="Gautami"/>
-        <a:font script="Taml" typeface="Latha"/>
-        <a:font script="Syrc" typeface="Estrangelo Edessa"/>
-        <a:font script="Orya" typeface="Kalinga"/>
-        <a:font script="Mlym" typeface="Kartika"/>
-        <a:font script="Laoo" typeface="DokChampa"/>
-        <a:font script="Sinh" typeface="Iskoola Pota"/>
-        <a:font script="Mong" typeface="Mongolian Baiti"/>
-        <a:font script="Viet" typeface="Times New Roman"/>
-        <a:font script="Uigh" typeface="Microsoft Uighur"/>
-        <a:font script="Geor" typeface="Sylfaen"/>
-        <a:font script="Armn" typeface="Arial"/>
-        <a:font script="Bugi" typeface="Leelawadee UI"/>
-        <a:font script="Bopo" typeface="Microsoft JhengHei"/>
-        <a:font script="Java" typeface="Javanese Text"/>
-        <a:font script="Lisu" typeface="Segoe UI"/>
-        <a:font script="Mymr" typeface="Myanmar Text"/>
-        <a:font script="Nkoo" typeface="Ebrima"/>
-        <a:font script="Olck" typeface="Nirmala UI"/>
-        <a:font script="Osma" typeface="Ebrima"/>
-        <a:font script="Phag" typeface="Phagspa"/>
-        <a:font script="Syrn" typeface="Estrangelo Edessa"/>
-        <a:font script="Syrj" typeface="Estrangelo Edessa"/>
-        <a:font script="Syre" typeface="Estrangelo Edessa"/>
-        <a:font script="Sora" typeface="Nirmala UI"/>
-        <a:font script="Tale" typeface="Microsoft Tai Le"/>
-        <a:font script="Talu" typeface="Microsoft New Tai Lue"/>
-        <a:font script="Tfng" typeface="Ebrima"/>
-      </a:majorFont>
-      <a:minorFont>
-        <a:latin typeface="Aptos" panose="02110004020202020204"/>
-        <a:ea typeface=""/>
-        <a:cs typeface=""/>
-        <a:font script="Jpan" typeface="游ゴシック"/>
-        <a:font script="Hang" typeface="맑은 고딕"/>
-        <a:font script="Hans" typeface="等线"/>
-        <a:font script="Hant" typeface="新細明體"/>
-        <a:font script="Arab" typeface="Arial"/>
-        <a:font script="Hebr" typeface="Arial"/>
-        <a:font script="Thai" typeface="Cordia New"/>
-        <a:font script="Ethi" typeface="Nyala"/>
-        <a:font script="Beng" typeface="Vrinda"/>
-        <a:font script="Gujr" typeface="Shruti"/>
-        <a:font script="Khmr" typeface="DaunPenh"/>
-        <a:font script="Knda" typeface="Tunga"/>
-        <a:font script="Guru" typeface="Raavi"/>
-        <a:font script="Cans" typeface="Euphemia"/>
-        <a:font script="Cher" typeface="Plantagenet Cherokee"/>
-        <a:font script="Yiii" typeface="Microsoft Yi Baiti"/>
-        <a:font script="Tibt" typeface="Microsoft Himalaya"/>
-        <a:font script="Thaa" typeface="MV Boli"/>
-        <a:font script="Deva" typeface="Mangal"/>
-        <a:font script="Telu" typeface="Gautami"/>
-        <a:font script="Taml" typeface="Latha"/>
-        <a:font script="Syrc" typeface="Estrangelo Edessa"/>
-        <a:font script="Orya" typeface="Kalinga"/>
-        <a:font script="Mlym" typeface="Kartika"/>
-        <a:font script="Laoo" typeface="DokChampa"/>
-        <a:font script="Sinh" typeface="Iskoola Pota"/>
-        <a:font script="Mong" typeface="Mongolian Baiti"/>
-        <a:font script="Viet" typeface="Arial"/>
-        <a:font script="Uigh" typeface="Microsoft Uighur"/>
-        <a:font script="Geor" typeface="Sylfaen"/>
-        <a:font script="Armn" typeface="Arial"/>
-        <a:font script="Bugi" typeface="Leelawadee UI"/>
-        <a:font script="Bopo" typeface="Microsoft JhengHei"/>
-        <a:font script="Java" typeface="Javanese Text"/>
-        <a:font script="Lisu" typeface="Segoe UI"/>
-        <a:font script="Mymr" typeface="Myanmar Text"/>
-        <a:font script="Nkoo" typeface="Ebrima"/>
-        <a:font script="Olck" typeface="Nirmala UI"/>
-        <a:font script="Osma" typeface="Ebrima"/>
-        <a:font script="Phag" typeface="Phagspa"/>
-        <a:font script="Syrn" typeface="Estrangelo Edessa"/>
-        <a:font script="Syrj" typeface="Estrangelo Edessa"/>
-        <a:font script="Syre" typeface="Estrangelo Edessa"/>
-        <a:font script="Sora" typeface="Nirmala UI"/>
-        <a:font script="Tale" typeface="Microsoft Tai Le"/>
-        <a:font script="Talu" typeface="Microsoft New Tai Lue"/>
-        <a:font script="Tfng" typeface="Ebrima"/>
-      </a:minorFont>
-    </a:fontScheme>
-    <a:fmtScheme name="Office">
-      <a:fillStyleLst>
-        <a:solidFill>
-          <a:schemeClr val="phClr"/>
-        </a:solidFill>
-        <a:gradFill rotWithShape="1">
-          <a:gsLst>
-            <a:gs pos="0">
-              <a:schemeClr val="phClr">
-                <a:lumMod val="110000"/>
-                <a:satMod val="105000"/>
-                <a:tint val="67000"/>
-              </a:schemeClr>
-            </a:gs>
-            <a:gs pos="50000">
-              <a:schemeClr val="phClr">
-                <a:lumMod val="105000"/>
-                <a:satMod val="103000"/>
-                <a:tint val="73000"/>
-              </a:schemeClr>
-            </a:gs>
-            <a:gs pos="100000">
-              <a:schemeClr val="phClr">
-                <a:lumMod val="105000"/>
-                <a:satMod val="109000"/>
-                <a:tint val="81000"/>
-              </a:schemeClr>
-            </a:gs>
-          </a:gsLst>
-          <a:lin ang="5400000" scaled="0"/>
-        </a:gradFill>
-        <a:gradFill rotWithShape="1">
-          <a:gsLst>
-            <a:gs pos="0">
-              <a:schemeClr val="phClr">
-                <a:satMod val="103000"/>
-                <a:lumMod val="102000"/>
-                <a:tint val="94000"/>
-              </a:schemeClr>
-            </a:gs>
-            <a:gs pos="50000">
-              <a:schemeClr val="phClr">
-                <a:satMod val="110000"/>
-                <a:lumMod val="100000"/>
-                <a:shade val="100000"/>
-              </a:schemeClr>
-            </a:gs>
-            <a:gs pos="100000">
-              <a:schemeClr val="phClr">
-                <a:lumMod val="99000"/>
-                <a:satMod val="120000"/>
-                <a:shade val="78000"/>
-              </a:schemeClr>
-            </a:gs>
-          </a:gsLst>
-          <a:lin ang="5400000" scaled="0"/>
-        </a:gradFill>
-      </a:fillStyleLst>
-      <a:lnStyleLst>
-        <a:ln w="12700" cap="flat" cmpd="sng" algn="ctr">
-          <a:solidFill>
-            <a:schemeClr val="phClr"/>
-          </a:solidFill>
-          <a:prstDash val="solid"/>
-          <a:miter lim="800000"/>
-        </a:ln>
-        <a:ln w="19050" cap="flat" cmpd="sng" algn="ctr">
-          <a:solidFill>
-            <a:schemeClr val="phClr"/>
-          </a:solidFill>
-          <a:prstDash val="solid"/>
-          <a:miter lim="800000"/>
-        </a:ln>
-        <a:ln w="25400" cap="flat" cmpd="sng" algn="ctr">
-          <a:solidFill>
-            <a:schemeClr val="phClr"/>
-          </a:solidFill>
-          <a:prstDash val="solid"/>
-          <a:miter lim="800000"/>
-        </a:ln>
-      </a:lnStyleLst>
-      <a:effectStyleLst>
-        <a:effectStyle>
-          <a:effectLst/>
-        </a:effectStyle>
-        <a:effectStyle>
-          <a:effectLst/>
-        </a:effectStyle>
-        <a:effectStyle>
-          <a:effectLst>
-            <a:outerShdw blurRad="57150" dist="19050" dir="5400000" algn="ctr" rotWithShape="0">
-              <a:srgbClr val="000000">
-                <a:alpha val="63000"/>
-              </a:srgbClr>
-            </a:outerShdw>
-          </a:effectLst>
-        </a:effectStyle>
-      </a:effectStyleLst>
-      <a:bgFillStyleLst>
-        <a:solidFill>
-          <a:schemeClr val="phClr"/>
-        </a:solidFill>
-        <a:solidFill>
-          <a:schemeClr val="phClr">
-            <a:tint val="95000"/>
-            <a:satMod val="170000"/>
-          </a:schemeClr>
-        </a:solidFill>
-        <a:gradFill rotWithShape="1">
-          <a:gsLst>
-            <a:gs pos="0">
-              <a:schemeClr val="phClr">
-                <a:tint val="93000"/>
-                <a:satMod val="150000"/>
-                <a:shade val="98000"/>
-                <a:lumMod val="102000"/>
-              </a:schemeClr>
-            </a:gs>
-            <a:gs pos="50000">
-              <a:schemeClr val="phClr">
-                <a:tint val="98000"/>
-                <a:satMod val="130000"/>
-                <a:shade val="90000"/>
-                <a:lumMod val="103000"/>
-              </a:schemeClr>
-            </a:gs>
-            <a:gs pos="100000">
-              <a:schemeClr val="phClr">
-                <a:shade val="63000"/>
-                <a:satMod val="120000"/>
-              </a:schemeClr>
-            </a:gs>
-          </a:gsLst>
-          <a:lin ang="5400000" scaled="0"/>
-        </a:gradFill>
-      </a:bgFillStyleLst>
-    </a:fmtScheme>
-  </a:themeElements>
-  <a:objectDefaults>
-    <a:lnDef>
-      <a:spPr/>
-      <a:bodyPr/>
-      <a:lstStyle/>
-      <a:style>
-        <a:lnRef idx="2">
-          <a:schemeClr val="accent1"/>
-        </a:lnRef>
-        <a:fillRef idx="0">
-          <a:schemeClr val="accent1"/>
-        </a:fillRef>
-        <a:effectRef idx="1">
-          <a:schemeClr val="accent1"/>
-        </a:effectRef>
-        <a:fontRef idx="minor">
-          <a:schemeClr val="tx1"/>
-        </a:fontRef>
-      </a:style>
-    </a:lnDef>
-  </a:objectDefaults>
-  <a:extraClrSchemeLst/>
-  <a:extLst>
-    <a:ext uri="{05A4C25C-085E-4340-85A3-A5531E510DB2}">
-      <thm15:themeFamily xmlns:thm15="http://schemas.microsoft.com/office/thememl/2012/main" name="Office Theme" id="{2E142A2C-CD16-42D6-873A-C26D2A0506FA}" vid="{1BDDFF52-6CD6-40A5-AB3C-68EB2F1E4D0A}"/>
-    </a:ext>
-  </a:extLst>
 </a:theme>
 </file>
</xml_diff>